<commit_message>
Complete step-by-step visual guides for Lab 02
</commit_message>
<xml_diff>
--- a/slides/LAB02_Linux_Hands_On_Final.pptx
+++ b/slides/LAB02_Linux_Hands_On_Final.pptx
@@ -44,6 +44,8 @@
     <p:sldId id="289" r:id="rId35"/>
     <p:sldId id="290" r:id="rId36"/>
     <p:sldId id="291" r:id="rId37"/>
+    <p:sldId id="292" r:id="rId43"/>
+    <p:sldId id="293" r:id="rId44"/>
   </p:sldIdLst>
   <p:sldSz cx="12192000" cy="6858000"/>
   <p:notesSz cx="6858000" cy="12192000"/>
@@ -34966,6 +34968,1318 @@
         <p14:creationId xmlns:p14="http://schemas.microsoft.com/office/powerpoint/2010/main" val="2811499213"/>
       </p:ext>
     </p:extLst>
+  </p:cSld>
+  <p:clrMapOvr>
+    <a:masterClrMapping/>
+  </p:clrMapOvr>
+</p:sld>
+</file>
+
+<file path=ppt/slides/slide37.xml><?xml version="1.0" encoding="utf-8"?>
+<p:sld xmlns:a="http://schemas.openxmlformats.org/drawingml/2006/main" xmlns:p="http://schemas.openxmlformats.org/presentationml/2006/main" xmlns:r="http://schemas.openxmlformats.org/officeDocument/2006/relationships">
+  <p:cSld>
+    <p:spTree>
+      <p:nvGrpSpPr>
+        <p:cNvPr id="1" name=""/>
+        <p:cNvGrpSpPr/>
+        <p:nvPr/>
+      </p:nvGrpSpPr>
+      <p:grpSpPr/>
+      <p:sp>
+        <p:nvSpPr>
+          <p:cNvPr id="2" name="Text 0"/>
+          <p:cNvSpPr/>
+          <p:nvPr/>
+        </p:nvSpPr>
+        <p:spPr>
+          <a:xfrm>
+            <a:off x="457200" y="6492240"/>
+            <a:ext cx="7315200" cy="274320"/>
+          </a:xfrm>
+          <a:prstGeom prst="rect">
+            <a:avLst/>
+          </a:prstGeom>
+          <a:noFill/>
+          <a:ln/>
+        </p:spPr>
+        <p:txBody>
+          <a:bodyPr wrap="square" lIns="0" tIns="0" rIns="0" bIns="0" rtlCol="0" anchor="ctr"/>
+          <a:lstStyle/>
+          <a:p>
+            <a:pPr marL="0" indent="0" algn="l">
+              <a:buNone/>
+            </a:pPr>
+            <a:r>
+              <a:rPr lang="en-US" sz="900" dirty="0">
+                <a:solidFill>
+                  <a:srgbClr val="64748B"/>
+                </a:solidFill>
+                <a:latin typeface="Calibri" pitchFamily="34" charset="0"/>
+                <a:ea typeface="Calibri" pitchFamily="34" charset="-122"/>
+                <a:cs typeface="Calibri" pitchFamily="34" charset="-120"/>
+              </a:rPr>
+              <a:t>BINUS UNIVERSITY  |  Cloud Services  |  Praktikum 2</a:t>
+            </a:r>
+            <a:endParaRPr lang="en-US" sz="900" dirty="0"/>
+          </a:p>
+        </p:txBody>
+      </p:sp>
+      <p:sp>
+        <p:nvSpPr>
+          <p:cNvPr id="3" name="Text 1"/>
+          <p:cNvSpPr/>
+          <p:nvPr/>
+        </p:nvSpPr>
+        <p:spPr>
+          <a:xfrm>
+            <a:off x="11247120" y="6492240"/>
+            <a:ext cx="457200" cy="274320"/>
+          </a:xfrm>
+          <a:prstGeom prst="rect">
+            <a:avLst/>
+          </a:prstGeom>
+          <a:noFill/>
+          <a:ln/>
+        </p:spPr>
+        <p:txBody>
+          <a:bodyPr wrap="square" lIns="0" tIns="0" rIns="0" bIns="0" rtlCol="0" anchor="ctr"/>
+          <a:lstStyle/>
+          <a:p>
+            <a:pPr marL="0" indent="0" algn="r">
+              <a:buNone/>
+            </a:pPr>
+            <a:r>
+              <a:rPr lang="en-US" sz="900" b="1">
+                <a:solidFill>
+                  <a:srgbClr val="64748B"/>
+                </a:solidFill>
+                <a:latin typeface="Calibri" pitchFamily="34" charset="0"/>
+                <a:ea typeface="Calibri" pitchFamily="34" charset="-122"/>
+                <a:cs typeface="Calibri" pitchFamily="34" charset="-120"/>
+              </a:rPr>
+              <a:t>37</a:t>
+            </a:r>
+            <a:endParaRPr lang="en-US" sz="900" dirty="0"/>
+          </a:p>
+        </p:txBody>
+      </p:sp>
+      <p:sp>
+        <p:nvSpPr>
+          <p:cNvPr id="4" name="Shape 2"/>
+          <p:cNvSpPr/>
+          <p:nvPr/>
+        </p:nvSpPr>
+        <p:spPr>
+          <a:xfrm>
+            <a:off x="457200" y="6446520"/>
+            <a:ext cx="228600" cy="36576"/>
+          </a:xfrm>
+          <a:prstGeom prst="rect">
+            <a:avLst/>
+          </a:prstGeom>
+          <a:solidFill>
+            <a:srgbClr val="F37021"/>
+          </a:solidFill>
+          <a:ln w="12700">
+            <a:solidFill>
+              <a:srgbClr val="F37021"/>
+            </a:solidFill>
+            <a:prstDash val="solid"/>
+          </a:ln>
+        </p:spPr>
+      </p:sp>
+      <p:pic>
+        <p:nvPicPr>
+          <p:cNvPr id="5" name="Picture 4" descr="image.png"/>
+          <p:cNvPicPr>
+            <a:picLocks noChangeAspect="1"/>
+          </p:cNvPicPr>
+          <p:nvPr/>
+        </p:nvPicPr>
+        <p:blipFill>
+          <a:blip r:embed="rId2"/>
+          <a:stretch>
+            <a:fillRect/>
+          </a:stretch>
+        </p:blipFill>
+        <p:spPr>
+          <a:xfrm>
+            <a:off x="274320" y="164592"/>
+            <a:ext cx="914400" cy="603504"/>
+          </a:xfrm>
+          <a:prstGeom prst="rect">
+            <a:avLst/>
+          </a:prstGeom>
+        </p:spPr>
+      </p:pic>
+      <p:pic>
+        <p:nvPicPr>
+          <p:cNvPr id="6" name="Picture 5" descr="image.png"/>
+          <p:cNvPicPr>
+            <a:picLocks noChangeAspect="1"/>
+          </p:cNvPicPr>
+          <p:nvPr/>
+        </p:nvPicPr>
+        <p:blipFill>
+          <a:blip r:embed="rId3"/>
+          <a:stretch>
+            <a:fillRect/>
+          </a:stretch>
+        </p:blipFill>
+        <p:spPr>
+          <a:xfrm>
+            <a:off x="10881360" y="182880"/>
+            <a:ext cx="1005840" cy="512064"/>
+          </a:xfrm>
+          <a:prstGeom prst="rect">
+            <a:avLst/>
+          </a:prstGeom>
+        </p:spPr>
+      </p:pic>
+      <p:sp>
+        <p:nvSpPr>
+          <p:cNvPr id="7" name="Shape 3"/>
+          <p:cNvSpPr/>
+          <p:nvPr/>
+        </p:nvSpPr>
+        <p:spPr>
+          <a:xfrm>
+            <a:off x="457200" y="868680"/>
+            <a:ext cx="11247120" cy="0"/>
+          </a:xfrm>
+          <a:prstGeom prst="line">
+            <a:avLst/>
+          </a:prstGeom>
+          <a:noFill/>
+          <a:ln w="12700">
+            <a:solidFill>
+              <a:srgbClr val="E2E8F0"/>
+            </a:solidFill>
+            <a:prstDash val="solid"/>
+          </a:ln>
+        </p:spPr>
+      </p:sp>
+      <p:sp>
+        <p:nvSpPr>
+          <p:cNvPr id="8" name="Text 4"/>
+          <p:cNvSpPr/>
+          <p:nvPr/>
+        </p:nvSpPr>
+        <p:spPr>
+          <a:xfrm>
+            <a:off x="2011680" y="182880"/>
+            <a:ext cx="8138160" cy="502920"/>
+          </a:xfrm>
+          <a:prstGeom prst="rect">
+            <a:avLst/>
+          </a:prstGeom>
+          <a:noFill/>
+          <a:ln/>
+        </p:spPr>
+        <p:txBody>
+          <a:bodyPr wrap="square" lIns="0" tIns="0" rIns="0" bIns="0" rtlCol="0" anchor="ctr"/>
+          <a:lstStyle/>
+          <a:p>
+            <a:pPr marL="0" indent="0" algn="ctr">
+              <a:buNone/>
+            </a:pPr>
+            <a:r>
+              <a:rPr lang="nl-NL" sz="2200" b="1">
+                <a:solidFill>
+                  <a:srgbClr val="1976D2"/>
+                </a:solidFill>
+                <a:latin typeface="Calibri" pitchFamily="34" charset="0"/>
+                <a:ea typeface="Calibri" pitchFamily="34" charset="-122"/>
+                <a:cs typeface="Calibri" pitchFamily="34" charset="-120"/>
+              </a:rPr>
+              <a:t>Bukti langkah 4 | kode status HTTP</a:t>
+            </a:r>
+            <a:endParaRPr lang="en-US" sz="2200" dirty="0"/>
+          </a:p>
+        </p:txBody>
+      </p:sp>
+      <p:sp>
+        <p:nvSpPr>
+          <p:cNvPr id="9" name="Text 5"/>
+          <p:cNvSpPr/>
+          <p:nvPr/>
+        </p:nvSpPr>
+        <p:spPr>
+          <a:xfrm>
+            <a:off x="457200" y="960120"/>
+            <a:ext cx="11247120" cy="320040"/>
+          </a:xfrm>
+          <a:prstGeom prst="rect">
+            <a:avLst/>
+          </a:prstGeom>
+          <a:noFill/>
+          <a:ln/>
+        </p:spPr>
+        <p:txBody>
+          <a:bodyPr wrap="square" lIns="0" tIns="0" rIns="0" bIns="0" rtlCol="0" anchor="ctr"/>
+          <a:lstStyle/>
+          <a:p>
+            <a:pPr marL="0" indent="0" algn="ctr">
+              <a:buNone/>
+            </a:pPr>
+            <a:r>
+              <a:rPr lang="en-US" sz="1200" i="1">
+                <a:solidFill>
+                  <a:srgbClr val="64748B"/>
+                </a:solidFill>
+                <a:latin typeface="Calibri" pitchFamily="34" charset="0"/>
+                <a:ea typeface="Calibri" pitchFamily="34" charset="-122"/>
+                <a:cs typeface="Calibri" pitchFamily="34" charset="-120"/>
+              </a:rPr>
+              <a:t>lima input, exit code, verifier  |  output aktual dari salinan solusi</a:t>
+            </a:r>
+            <a:endParaRPr lang="en-US" sz="1200" dirty="0"/>
+          </a:p>
+        </p:txBody>
+      </p:sp>
+      <p:sp>
+        <p:nvSpPr>
+          <p:cNvPr id="27" name="Rectangle 26">
+            <a:extLst>
+              <a:ext uri="{FF2B5EF4-FFF2-40B4-BE49-F238E27FC236}">
+                <a16:creationId xmlns:a16="http://schemas.microsoft.com/office/drawing/2014/main" id="{CA2C3FC3-2268-3632-60A5-8F36FCCD90BB}"/>
+              </a:ext>
+            </a:extLst>
+          </p:cNvPr>
+          <p:cNvSpPr/>
+          <p:nvPr/>
+        </p:nvSpPr>
+        <p:spPr>
+          <a:xfrm>
+            <a:off x="457200" y="1409700"/>
+            <a:ext cx="11252200" cy="3886200"/>
+          </a:xfrm>
+          <a:prstGeom prst="rect">
+            <a:avLst/>
+          </a:prstGeom>
+          <a:solidFill>
+            <a:srgbClr val="F6F8FC"/>
+          </a:solidFill>
+          <a:ln>
+            <a:solidFill>
+              <a:srgbClr val="D3DEEE"/>
+            </a:solidFill>
+          </a:ln>
+        </p:spPr>
+        <p:style>
+          <a:lnRef idx="2">
+            <a:schemeClr val="accent1">
+              <a:shade val="15000"/>
+            </a:schemeClr>
+          </a:lnRef>
+          <a:fillRef idx="1">
+            <a:schemeClr val="accent1"/>
+          </a:fillRef>
+          <a:effectRef idx="0">
+            <a:schemeClr val="accent1"/>
+          </a:effectRef>
+          <a:fontRef idx="minor">
+            <a:schemeClr val="lt1"/>
+          </a:fontRef>
+        </p:style>
+        <p:txBody>
+          <a:bodyPr rtlCol="0" anchor="ctr"/>
+          <a:lstStyle/>
+          <a:p>
+            <a:pPr algn="ctr"/>
+            <a:endParaRPr lang="en-US"/>
+          </a:p>
+        </p:txBody>
+      </p:sp>
+      <p:sp>
+        <p:nvSpPr>
+          <p:cNvPr id="30" name="Rectangle 29">
+            <a:extLst>
+              <a:ext uri="{FF2B5EF4-FFF2-40B4-BE49-F238E27FC236}">
+                <a16:creationId xmlns:a16="http://schemas.microsoft.com/office/drawing/2014/main" id="{784C38AF-D50D-3EDB-2A20-35E588144107}"/>
+              </a:ext>
+            </a:extLst>
+          </p:cNvPr>
+          <p:cNvSpPr/>
+          <p:nvPr/>
+        </p:nvSpPr>
+        <p:spPr>
+          <a:xfrm>
+            <a:off x="457200" y="5397500"/>
+            <a:ext cx="11252200" cy="787400"/>
+          </a:xfrm>
+          <a:prstGeom prst="rect">
+            <a:avLst/>
+          </a:prstGeom>
+          <a:solidFill>
+            <a:srgbClr val="002777"/>
+          </a:solidFill>
+          <a:ln w="12700" cap="flat" cmpd="sng" algn="ctr">
+            <a:noFill/>
+            <a:prstDash val="solid"/>
+            <a:miter lim="800000"/>
+          </a:ln>
+          <a:effectLst/>
+          <a:extLst>
+            <a:ext uri="{91240B29-F687-4F45-9708-019B960494DF}">
+              <a14:hiddenLine xmlns:a14="http://schemas.microsoft.com/office/drawing/2010/main" w="12700" cap="flat" cmpd="sng" algn="ctr">
+                <a:solidFill>
+                  <a:schemeClr val="accent1">
+                    <a:shade val="15000"/>
+                  </a:schemeClr>
+                </a:solidFill>
+                <a:prstDash val="solid"/>
+                <a:miter lim="800000"/>
+              </a14:hiddenLine>
+            </a:ext>
+          </a:extLst>
+        </p:spPr>
+        <p:style>
+          <a:lnRef idx="2">
+            <a:schemeClr val="accent1">
+              <a:shade val="15000"/>
+            </a:schemeClr>
+          </a:lnRef>
+          <a:fillRef idx="1">
+            <a:schemeClr val="accent1"/>
+          </a:fillRef>
+          <a:effectRef idx="0">
+            <a:schemeClr val="accent1"/>
+          </a:effectRef>
+          <a:fontRef idx="minor">
+            <a:schemeClr val="lt1"/>
+          </a:fontRef>
+        </p:style>
+        <p:txBody>
+          <a:bodyPr rtlCol="0" anchor="ctr"/>
+          <a:lstStyle/>
+          <a:p>
+            <a:pPr algn="ctr"/>
+            <a:endParaRPr lang="en-US"/>
+          </a:p>
+        </p:txBody>
+      </p:sp>
+      <p:sp>
+        <p:nvSpPr>
+          <p:cNvPr id="31" name="TextBox 30">
+            <a:extLst>
+              <a:ext uri="{FF2B5EF4-FFF2-40B4-BE49-F238E27FC236}">
+                <a16:creationId xmlns:a16="http://schemas.microsoft.com/office/drawing/2014/main" id="{78179848-0254-FC95-B234-981E0248F004}"/>
+              </a:ext>
+            </a:extLst>
+          </p:cNvPr>
+          <p:cNvSpPr txBox="1"/>
+          <p:nvPr/>
+        </p:nvSpPr>
+        <p:spPr>
+          <a:xfrm>
+            <a:off x="635000" y="5499100"/>
+            <a:ext cx="3429000" cy="276999"/>
+          </a:xfrm>
+          <a:prstGeom prst="rect">
+            <a:avLst/>
+          </a:prstGeom>
+          <a:noFill/>
+        </p:spPr>
+        <p:txBody>
+          <a:bodyPr vert="horz" wrap="square" lIns="0" tIns="0" rIns="0" bIns="0" rtlCol="0">
+            <a:noAutofit/>
+          </a:bodyPr>
+          <a:lstStyle/>
+          <a:p>
+            <a:r>
+              <a:rPr lang="en-US" sz="1050" b="1">
+                <a:solidFill>
+                  <a:srgbClr val="F37021"/>
+                </a:solidFill>
+                <a:latin typeface="Arial" panose="020B0604020202020204" pitchFamily="34" charset="0"/>
+              </a:rPr>
+              <a:t>KODE VALID</a:t>
+            </a:r>
+          </a:p>
+        </p:txBody>
+      </p:sp>
+      <p:sp>
+        <p:nvSpPr>
+          <p:cNvPr id="32" name="TextBox 31">
+            <a:extLst>
+              <a:ext uri="{FF2B5EF4-FFF2-40B4-BE49-F238E27FC236}">
+                <a16:creationId xmlns:a16="http://schemas.microsoft.com/office/drawing/2014/main" id="{9F041FD0-C768-9242-FF37-021E9D2B6BD9}"/>
+              </a:ext>
+            </a:extLst>
+          </p:cNvPr>
+          <p:cNvSpPr txBox="1"/>
+          <p:nvPr/>
+        </p:nvSpPr>
+        <p:spPr>
+          <a:xfrm>
+            <a:off x="635000" y="5727700"/>
+            <a:ext cx="3429000" cy="276999"/>
+          </a:xfrm>
+          <a:prstGeom prst="rect">
+            <a:avLst/>
+          </a:prstGeom>
+          <a:noFill/>
+        </p:spPr>
+        <p:txBody>
+          <a:bodyPr vert="horz" wrap="square" lIns="0" tIns="0" rIns="0" bIns="0" rtlCol="0">
+            <a:noAutofit/>
+          </a:bodyPr>
+          <a:lstStyle/>
+          <a:p>
+            <a:r>
+              <a:rPr lang="en-US" sz="1300">
+                <a:solidFill>
+                  <a:srgbClr val="FFFFFF"/>
+                </a:solidFill>
+                <a:latin typeface="Arial" panose="020B0604020202020204" pitchFamily="34" charset="0"/>
+              </a:rPr>
+              <a:t>103/200/302/503</a:t>
+            </a:r>
+          </a:p>
+        </p:txBody>
+      </p:sp>
+      <p:sp>
+        <p:nvSpPr>
+          <p:cNvPr id="33" name="TextBox 32">
+            <a:extLst>
+              <a:ext uri="{FF2B5EF4-FFF2-40B4-BE49-F238E27FC236}">
+                <a16:creationId xmlns:a16="http://schemas.microsoft.com/office/drawing/2014/main" id="{AF74B100-F150-BE1A-A13C-CBD2FCE7D19B}"/>
+              </a:ext>
+            </a:extLst>
+          </p:cNvPr>
+          <p:cNvSpPr txBox="1"/>
+          <p:nvPr/>
+        </p:nvSpPr>
+        <p:spPr>
+          <a:xfrm>
+            <a:off x="4318000" y="5499100"/>
+            <a:ext cx="3429000" cy="276999"/>
+          </a:xfrm>
+          <a:prstGeom prst="rect">
+            <a:avLst/>
+          </a:prstGeom>
+          <a:noFill/>
+        </p:spPr>
+        <p:txBody>
+          <a:bodyPr vert="horz" wrap="square" lIns="0" tIns="0" rIns="0" bIns="0" rtlCol="0">
+            <a:noAutofit/>
+          </a:bodyPr>
+          <a:lstStyle/>
+          <a:p>
+            <a:r>
+              <a:rPr lang="en-US" sz="1050" b="1">
+                <a:solidFill>
+                  <a:srgbClr val="F37021"/>
+                </a:solidFill>
+                <a:latin typeface="Arial" panose="020B0604020202020204" pitchFamily="34" charset="0"/>
+              </a:rPr>
+              <a:t>INPUT SALAH</a:t>
+            </a:r>
+          </a:p>
+        </p:txBody>
+      </p:sp>
+      <p:sp>
+        <p:nvSpPr>
+          <p:cNvPr id="34" name="TextBox 33">
+            <a:extLst>
+              <a:ext uri="{FF2B5EF4-FFF2-40B4-BE49-F238E27FC236}">
+                <a16:creationId xmlns:a16="http://schemas.microsoft.com/office/drawing/2014/main" id="{B864305D-94C1-CBA2-4912-2EC5B118054C}"/>
+              </a:ext>
+            </a:extLst>
+          </p:cNvPr>
+          <p:cNvSpPr txBox="1"/>
+          <p:nvPr/>
+        </p:nvSpPr>
+        <p:spPr>
+          <a:xfrm>
+            <a:off x="4318000" y="5727700"/>
+            <a:ext cx="3429000" cy="276999"/>
+          </a:xfrm>
+          <a:prstGeom prst="rect">
+            <a:avLst/>
+          </a:prstGeom>
+          <a:noFill/>
+        </p:spPr>
+        <p:txBody>
+          <a:bodyPr vert="horz" wrap="square" lIns="0" tIns="0" rIns="0" bIns="0" rtlCol="0">
+            <a:noAutofit/>
+          </a:bodyPr>
+          <a:lstStyle/>
+          <a:p>
+            <a:r>
+              <a:rPr lang="en-US" sz="1300">
+                <a:solidFill>
+                  <a:srgbClr val="FFFFFF"/>
+                </a:solidFill>
+                <a:latin typeface="Arial" panose="020B0604020202020204" pitchFamily="34" charset="0"/>
+              </a:rPr>
+              <a:t>99 keluar dengan kode 2</a:t>
+            </a:r>
+          </a:p>
+        </p:txBody>
+      </p:sp>
+      <p:sp>
+        <p:nvSpPr>
+          <p:cNvPr id="35" name="TextBox 34">
+            <a:extLst>
+              <a:ext uri="{FF2B5EF4-FFF2-40B4-BE49-F238E27FC236}">
+                <a16:creationId xmlns:a16="http://schemas.microsoft.com/office/drawing/2014/main" id="{7FEE0EF9-5060-12FC-A5E6-E5367599FF83}"/>
+              </a:ext>
+            </a:extLst>
+          </p:cNvPr>
+          <p:cNvSpPr txBox="1"/>
+          <p:nvPr/>
+        </p:nvSpPr>
+        <p:spPr>
+          <a:xfrm>
+            <a:off x="8001000" y="5499100"/>
+            <a:ext cx="3429000" cy="276999"/>
+          </a:xfrm>
+          <a:prstGeom prst="rect">
+            <a:avLst/>
+          </a:prstGeom>
+          <a:noFill/>
+        </p:spPr>
+        <p:txBody>
+          <a:bodyPr vert="horz" wrap="square" lIns="0" tIns="0" rIns="0" bIns="0" rtlCol="0">
+            <a:noAutofit/>
+          </a:bodyPr>
+          <a:lstStyle/>
+          <a:p>
+            <a:r>
+              <a:rPr lang="en-US" sz="1050" b="1">
+                <a:solidFill>
+                  <a:srgbClr val="F37021"/>
+                </a:solidFill>
+                <a:latin typeface="Arial" panose="020B0604020202020204" pitchFamily="34" charset="0"/>
+              </a:rPr>
+              <a:t>VERIFIER</a:t>
+            </a:r>
+          </a:p>
+        </p:txBody>
+      </p:sp>
+      <p:sp>
+        <p:nvSpPr>
+          <p:cNvPr id="36" name="TextBox 35">
+            <a:extLst>
+              <a:ext uri="{FF2B5EF4-FFF2-40B4-BE49-F238E27FC236}">
+                <a16:creationId xmlns:a16="http://schemas.microsoft.com/office/drawing/2014/main" id="{B7FAF8FA-E512-3BA5-B85A-15159888CAEB}"/>
+              </a:ext>
+            </a:extLst>
+          </p:cNvPr>
+          <p:cNvSpPr txBox="1"/>
+          <p:nvPr/>
+        </p:nvSpPr>
+        <p:spPr>
+          <a:xfrm>
+            <a:off x="8001000" y="5727700"/>
+            <a:ext cx="3429000" cy="276999"/>
+          </a:xfrm>
+          <a:prstGeom prst="rect">
+            <a:avLst/>
+          </a:prstGeom>
+          <a:noFill/>
+        </p:spPr>
+        <p:txBody>
+          <a:bodyPr vert="horz" wrap="square" lIns="0" tIns="0" rIns="0" bIns="0" rtlCol="0">
+            <a:noAutofit/>
+          </a:bodyPr>
+          <a:lstStyle/>
+          <a:p>
+            <a:r>
+              <a:rPr lang="en-US" sz="1300">
+                <a:solidFill>
+                  <a:srgbClr val="FFFFFF"/>
+                </a:solidFill>
+                <a:latin typeface="Arial" panose="020B0604020202020204" pitchFamily="34" charset="0"/>
+              </a:rPr>
+              <a:t>Hasil: 0 gagal</a:t>
+            </a:r>
+          </a:p>
+        </p:txBody>
+      </p:sp>
+      <p:pic>
+        <p:nvPicPr>
+          <p:cNvPr id="37" name="Picture 36" descr="image.png"/>
+          <p:cNvPicPr>
+            <a:picLocks noChangeAspect="1"/>
+          </p:cNvPicPr>
+          <p:nvPr/>
+        </p:nvPicPr>
+        <p:blipFill>
+          <a:blip r:embed="rId4"/>
+          <a:stretch>
+            <a:fillRect/>
+          </a:stretch>
+        </p:blipFill>
+        <p:spPr>
+          <a:xfrm>
+            <a:off x="1247191" y="1490898"/>
+            <a:ext cx="9672218" cy="3723804"/>
+          </a:xfrm>
+          <a:prstGeom prst="rect">
+            <a:avLst/>
+          </a:prstGeom>
+        </p:spPr>
+      </p:pic>
+    </p:spTree>
+  </p:cSld>
+  <p:clrMapOvr>
+    <a:masterClrMapping/>
+  </p:clrMapOvr>
+</p:sld>
+</file>
+
+<file path=ppt/slides/slide38.xml><?xml version="1.0" encoding="utf-8"?>
+<p:sld xmlns:a="http://schemas.openxmlformats.org/drawingml/2006/main" xmlns:p="http://schemas.openxmlformats.org/presentationml/2006/main" xmlns:r="http://schemas.openxmlformats.org/officeDocument/2006/relationships">
+  <p:cSld>
+    <p:spTree>
+      <p:nvGrpSpPr>
+        <p:cNvPr id="1" name=""/>
+        <p:cNvGrpSpPr/>
+        <p:nvPr/>
+      </p:nvGrpSpPr>
+      <p:grpSpPr/>
+      <p:sp>
+        <p:nvSpPr>
+          <p:cNvPr id="2" name="Text 0"/>
+          <p:cNvSpPr/>
+          <p:nvPr/>
+        </p:nvSpPr>
+        <p:spPr>
+          <a:xfrm>
+            <a:off x="457200" y="6492240"/>
+            <a:ext cx="7315200" cy="274320"/>
+          </a:xfrm>
+          <a:prstGeom prst="rect">
+            <a:avLst/>
+          </a:prstGeom>
+          <a:noFill/>
+          <a:ln/>
+        </p:spPr>
+        <p:txBody>
+          <a:bodyPr wrap="square" lIns="0" tIns="0" rIns="0" bIns="0" rtlCol="0" anchor="ctr"/>
+          <a:lstStyle/>
+          <a:p>
+            <a:pPr marL="0" indent="0" algn="l">
+              <a:buNone/>
+            </a:pPr>
+            <a:r>
+              <a:rPr lang="en-US" sz="900" dirty="0">
+                <a:solidFill>
+                  <a:srgbClr val="64748B"/>
+                </a:solidFill>
+                <a:latin typeface="Calibri" pitchFamily="34" charset="0"/>
+                <a:ea typeface="Calibri" pitchFamily="34" charset="-122"/>
+                <a:cs typeface="Calibri" pitchFamily="34" charset="-120"/>
+              </a:rPr>
+              <a:t>BINUS UNIVERSITY  |  Cloud Services  |  Praktikum 2</a:t>
+            </a:r>
+            <a:endParaRPr lang="en-US" sz="900" dirty="0"/>
+          </a:p>
+        </p:txBody>
+      </p:sp>
+      <p:sp>
+        <p:nvSpPr>
+          <p:cNvPr id="3" name="Text 1"/>
+          <p:cNvSpPr/>
+          <p:nvPr/>
+        </p:nvSpPr>
+        <p:spPr>
+          <a:xfrm>
+            <a:off x="11247120" y="6492240"/>
+            <a:ext cx="457200" cy="274320"/>
+          </a:xfrm>
+          <a:prstGeom prst="rect">
+            <a:avLst/>
+          </a:prstGeom>
+          <a:noFill/>
+          <a:ln/>
+        </p:spPr>
+        <p:txBody>
+          <a:bodyPr wrap="square" lIns="0" tIns="0" rIns="0" bIns="0" rtlCol="0" anchor="ctr"/>
+          <a:lstStyle/>
+          <a:p>
+            <a:pPr marL="0" indent="0" algn="r">
+              <a:buNone/>
+            </a:pPr>
+            <a:r>
+              <a:rPr lang="en-US" sz="900" b="1">
+                <a:solidFill>
+                  <a:srgbClr val="64748B"/>
+                </a:solidFill>
+                <a:latin typeface="Calibri" pitchFamily="34" charset="0"/>
+                <a:ea typeface="Calibri" pitchFamily="34" charset="-122"/>
+                <a:cs typeface="Calibri" pitchFamily="34" charset="-120"/>
+              </a:rPr>
+              <a:t>38</a:t>
+            </a:r>
+            <a:endParaRPr lang="en-US" sz="900" dirty="0"/>
+          </a:p>
+        </p:txBody>
+      </p:sp>
+      <p:sp>
+        <p:nvSpPr>
+          <p:cNvPr id="4" name="Shape 2"/>
+          <p:cNvSpPr/>
+          <p:nvPr/>
+        </p:nvSpPr>
+        <p:spPr>
+          <a:xfrm>
+            <a:off x="457200" y="6446520"/>
+            <a:ext cx="228600" cy="36576"/>
+          </a:xfrm>
+          <a:prstGeom prst="rect">
+            <a:avLst/>
+          </a:prstGeom>
+          <a:solidFill>
+            <a:srgbClr val="F37021"/>
+          </a:solidFill>
+          <a:ln w="12700">
+            <a:solidFill>
+              <a:srgbClr val="F37021"/>
+            </a:solidFill>
+            <a:prstDash val="solid"/>
+          </a:ln>
+        </p:spPr>
+      </p:sp>
+      <p:pic>
+        <p:nvPicPr>
+          <p:cNvPr id="5" name="Picture 4" descr="image.png"/>
+          <p:cNvPicPr>
+            <a:picLocks noChangeAspect="1"/>
+          </p:cNvPicPr>
+          <p:nvPr/>
+        </p:nvPicPr>
+        <p:blipFill>
+          <a:blip r:embed="rId2"/>
+          <a:stretch>
+            <a:fillRect/>
+          </a:stretch>
+        </p:blipFill>
+        <p:spPr>
+          <a:xfrm>
+            <a:off x="274320" y="164592"/>
+            <a:ext cx="914400" cy="603504"/>
+          </a:xfrm>
+          <a:prstGeom prst="rect">
+            <a:avLst/>
+          </a:prstGeom>
+        </p:spPr>
+      </p:pic>
+      <p:pic>
+        <p:nvPicPr>
+          <p:cNvPr id="6" name="Picture 5" descr="image.png"/>
+          <p:cNvPicPr>
+            <a:picLocks noChangeAspect="1"/>
+          </p:cNvPicPr>
+          <p:nvPr/>
+        </p:nvPicPr>
+        <p:blipFill>
+          <a:blip r:embed="rId3"/>
+          <a:stretch>
+            <a:fillRect/>
+          </a:stretch>
+        </p:blipFill>
+        <p:spPr>
+          <a:xfrm>
+            <a:off x="10881360" y="182880"/>
+            <a:ext cx="1005840" cy="512064"/>
+          </a:xfrm>
+          <a:prstGeom prst="rect">
+            <a:avLst/>
+          </a:prstGeom>
+        </p:spPr>
+      </p:pic>
+      <p:sp>
+        <p:nvSpPr>
+          <p:cNvPr id="7" name="Shape 3"/>
+          <p:cNvSpPr/>
+          <p:nvPr/>
+        </p:nvSpPr>
+        <p:spPr>
+          <a:xfrm>
+            <a:off x="457200" y="868680"/>
+            <a:ext cx="11247120" cy="0"/>
+          </a:xfrm>
+          <a:prstGeom prst="line">
+            <a:avLst/>
+          </a:prstGeom>
+          <a:noFill/>
+          <a:ln w="12700">
+            <a:solidFill>
+              <a:srgbClr val="E2E8F0"/>
+            </a:solidFill>
+            <a:prstDash val="solid"/>
+          </a:ln>
+        </p:spPr>
+      </p:sp>
+      <p:sp>
+        <p:nvSpPr>
+          <p:cNvPr id="8" name="Text 4"/>
+          <p:cNvSpPr/>
+          <p:nvPr/>
+        </p:nvSpPr>
+        <p:spPr>
+          <a:xfrm>
+            <a:off x="2011680" y="182880"/>
+            <a:ext cx="8138160" cy="502920"/>
+          </a:xfrm>
+          <a:prstGeom prst="rect">
+            <a:avLst/>
+          </a:prstGeom>
+          <a:noFill/>
+          <a:ln/>
+        </p:spPr>
+        <p:txBody>
+          <a:bodyPr wrap="square" lIns="0" tIns="0" rIns="0" bIns="0" rtlCol="0" anchor="ctr"/>
+          <a:lstStyle/>
+          <a:p>
+            <a:pPr marL="0" indent="0" algn="ctr">
+              <a:buNone/>
+            </a:pPr>
+            <a:r>
+              <a:rPr lang="nl-NL" sz="2200" b="1">
+                <a:solidFill>
+                  <a:srgbClr val="1976D2"/>
+                </a:solidFill>
+                <a:latin typeface="Calibri" pitchFamily="34" charset="0"/>
+                <a:ea typeface="Calibri" pitchFamily="34" charset="-122"/>
+                <a:cs typeface="Calibri" pitchFamily="34" charset="-120"/>
+              </a:rPr>
+              <a:t>Bukti Git | repo Lab 02 terbit</a:t>
+            </a:r>
+            <a:endParaRPr lang="en-US" sz="2200" dirty="0"/>
+          </a:p>
+        </p:txBody>
+      </p:sp>
+      <p:sp>
+        <p:nvSpPr>
+          <p:cNvPr id="9" name="Text 5"/>
+          <p:cNvSpPr/>
+          <p:nvPr/>
+        </p:nvSpPr>
+        <p:spPr>
+          <a:xfrm>
+            <a:off x="457200" y="960120"/>
+            <a:ext cx="11247120" cy="320040"/>
+          </a:xfrm>
+          <a:prstGeom prst="rect">
+            <a:avLst/>
+          </a:prstGeom>
+          <a:noFill/>
+          <a:ln/>
+        </p:spPr>
+        <p:txBody>
+          <a:bodyPr wrap="square" lIns="0" tIns="0" rIns="0" bIns="0" rtlCol="0" anchor="ctr"/>
+          <a:lstStyle/>
+          <a:p>
+            <a:pPr marL="0" indent="0" algn="ctr">
+              <a:buNone/>
+            </a:pPr>
+            <a:r>
+              <a:rPr lang="en-US" sz="1200" i="1">
+                <a:solidFill>
+                  <a:srgbClr val="64748B"/>
+                </a:solidFill>
+                <a:latin typeface="Calibri" pitchFamily="34" charset="0"/>
+                <a:ea typeface="Calibri" pitchFamily="34" charset="-122"/>
+                <a:cs typeface="Calibri" pitchFamily="34" charset="-120"/>
+              </a:rPr>
+              <a:t>remote, status, log, SHA main  |  contoh checkpoint pengajar</a:t>
+            </a:r>
+            <a:endParaRPr lang="en-US" sz="1200" dirty="0"/>
+          </a:p>
+        </p:txBody>
+      </p:sp>
+      <p:sp>
+        <p:nvSpPr>
+          <p:cNvPr id="27" name="Rectangle 26">
+            <a:extLst>
+              <a:ext uri="{FF2B5EF4-FFF2-40B4-BE49-F238E27FC236}">
+                <a16:creationId xmlns:a16="http://schemas.microsoft.com/office/drawing/2014/main" id="{CA2C3FC3-2268-3632-60A5-8F36FCCD90BB}"/>
+              </a:ext>
+            </a:extLst>
+          </p:cNvPr>
+          <p:cNvSpPr/>
+          <p:nvPr/>
+        </p:nvSpPr>
+        <p:spPr>
+          <a:xfrm>
+            <a:off x="457200" y="1409700"/>
+            <a:ext cx="11252200" cy="3886200"/>
+          </a:xfrm>
+          <a:prstGeom prst="rect">
+            <a:avLst/>
+          </a:prstGeom>
+          <a:solidFill>
+            <a:srgbClr val="F6F8FC"/>
+          </a:solidFill>
+          <a:ln>
+            <a:solidFill>
+              <a:srgbClr val="D3DEEE"/>
+            </a:solidFill>
+          </a:ln>
+        </p:spPr>
+        <p:style>
+          <a:lnRef idx="2">
+            <a:schemeClr val="accent1">
+              <a:shade val="15000"/>
+            </a:schemeClr>
+          </a:lnRef>
+          <a:fillRef idx="1">
+            <a:schemeClr val="accent1"/>
+          </a:fillRef>
+          <a:effectRef idx="0">
+            <a:schemeClr val="accent1"/>
+          </a:effectRef>
+          <a:fontRef idx="minor">
+            <a:schemeClr val="lt1"/>
+          </a:fontRef>
+        </p:style>
+        <p:txBody>
+          <a:bodyPr rtlCol="0" anchor="ctr"/>
+          <a:lstStyle/>
+          <a:p>
+            <a:pPr algn="ctr"/>
+            <a:endParaRPr lang="en-US"/>
+          </a:p>
+        </p:txBody>
+      </p:sp>
+      <p:sp>
+        <p:nvSpPr>
+          <p:cNvPr id="30" name="Rectangle 29">
+            <a:extLst>
+              <a:ext uri="{FF2B5EF4-FFF2-40B4-BE49-F238E27FC236}">
+                <a16:creationId xmlns:a16="http://schemas.microsoft.com/office/drawing/2014/main" id="{784C38AF-D50D-3EDB-2A20-35E588144107}"/>
+              </a:ext>
+            </a:extLst>
+          </p:cNvPr>
+          <p:cNvSpPr/>
+          <p:nvPr/>
+        </p:nvSpPr>
+        <p:spPr>
+          <a:xfrm>
+            <a:off x="457200" y="5397500"/>
+            <a:ext cx="11252200" cy="787400"/>
+          </a:xfrm>
+          <a:prstGeom prst="rect">
+            <a:avLst/>
+          </a:prstGeom>
+          <a:solidFill>
+            <a:srgbClr val="002777"/>
+          </a:solidFill>
+          <a:ln w="12700" cap="flat" cmpd="sng" algn="ctr">
+            <a:noFill/>
+            <a:prstDash val="solid"/>
+            <a:miter lim="800000"/>
+          </a:ln>
+          <a:effectLst/>
+          <a:extLst>
+            <a:ext uri="{91240B29-F687-4F45-9708-019B960494DF}">
+              <a14:hiddenLine xmlns:a14="http://schemas.microsoft.com/office/drawing/2010/main" w="12700" cap="flat" cmpd="sng" algn="ctr">
+                <a:solidFill>
+                  <a:schemeClr val="accent1">
+                    <a:shade val="15000"/>
+                  </a:schemeClr>
+                </a:solidFill>
+                <a:prstDash val="solid"/>
+                <a:miter lim="800000"/>
+              </a14:hiddenLine>
+            </a:ext>
+          </a:extLst>
+        </p:spPr>
+        <p:style>
+          <a:lnRef idx="2">
+            <a:schemeClr val="accent1">
+              <a:shade val="15000"/>
+            </a:schemeClr>
+          </a:lnRef>
+          <a:fillRef idx="1">
+            <a:schemeClr val="accent1"/>
+          </a:fillRef>
+          <a:effectRef idx="0">
+            <a:schemeClr val="accent1"/>
+          </a:effectRef>
+          <a:fontRef idx="minor">
+            <a:schemeClr val="lt1"/>
+          </a:fontRef>
+        </p:style>
+        <p:txBody>
+          <a:bodyPr rtlCol="0" anchor="ctr"/>
+          <a:lstStyle/>
+          <a:p>
+            <a:pPr algn="ctr"/>
+            <a:endParaRPr lang="en-US"/>
+          </a:p>
+        </p:txBody>
+      </p:sp>
+      <p:sp>
+        <p:nvSpPr>
+          <p:cNvPr id="31" name="TextBox 30">
+            <a:extLst>
+              <a:ext uri="{FF2B5EF4-FFF2-40B4-BE49-F238E27FC236}">
+                <a16:creationId xmlns:a16="http://schemas.microsoft.com/office/drawing/2014/main" id="{78179848-0254-FC95-B234-981E0248F004}"/>
+              </a:ext>
+            </a:extLst>
+          </p:cNvPr>
+          <p:cNvSpPr txBox="1"/>
+          <p:nvPr/>
+        </p:nvSpPr>
+        <p:spPr>
+          <a:xfrm>
+            <a:off x="635000" y="5499100"/>
+            <a:ext cx="3429000" cy="276999"/>
+          </a:xfrm>
+          <a:prstGeom prst="rect">
+            <a:avLst/>
+          </a:prstGeom>
+          <a:noFill/>
+        </p:spPr>
+        <p:txBody>
+          <a:bodyPr vert="horz" wrap="square" lIns="0" tIns="0" rIns="0" bIns="0" rtlCol="0">
+            <a:noAutofit/>
+          </a:bodyPr>
+          <a:lstStyle/>
+          <a:p>
+            <a:r>
+              <a:rPr lang="en-US" sz="1050" b="1">
+                <a:solidFill>
+                  <a:srgbClr val="F37021"/>
+                </a:solidFill>
+                <a:latin typeface="Arial" panose="020B0604020202020204" pitchFamily="34" charset="0"/>
+              </a:rPr>
+              <a:t>TUJUAN</a:t>
+            </a:r>
+          </a:p>
+        </p:txBody>
+      </p:sp>
+      <p:sp>
+        <p:nvSpPr>
+          <p:cNvPr id="32" name="TextBox 31">
+            <a:extLst>
+              <a:ext uri="{FF2B5EF4-FFF2-40B4-BE49-F238E27FC236}">
+                <a16:creationId xmlns:a16="http://schemas.microsoft.com/office/drawing/2014/main" id="{9F041FD0-C768-9242-FF37-021E9D2B6BD9}"/>
+              </a:ext>
+            </a:extLst>
+          </p:cNvPr>
+          <p:cNvSpPr txBox="1"/>
+          <p:nvPr/>
+        </p:nvSpPr>
+        <p:spPr>
+          <a:xfrm>
+            <a:off x="635000" y="5727700"/>
+            <a:ext cx="3429000" cy="276999"/>
+          </a:xfrm>
+          <a:prstGeom prst="rect">
+            <a:avLst/>
+          </a:prstGeom>
+          <a:noFill/>
+        </p:spPr>
+        <p:txBody>
+          <a:bodyPr vert="horz" wrap="square" lIns="0" tIns="0" rIns="0" bIns="0" rtlCol="0">
+            <a:noAutofit/>
+          </a:bodyPr>
+          <a:lstStyle/>
+          <a:p>
+            <a:r>
+              <a:rPr lang="en-US" sz="1300">
+                <a:solidFill>
+                  <a:srgbClr val="FFFFFF"/>
+                </a:solidFill>
+                <a:latin typeface="Arial" panose="020B0604020202020204" pitchFamily="34" charset="0"/>
+              </a:rPr>
+              <a:t>origin = meet2CloudService</a:t>
+            </a:r>
+          </a:p>
+        </p:txBody>
+      </p:sp>
+      <p:sp>
+        <p:nvSpPr>
+          <p:cNvPr id="33" name="TextBox 32">
+            <a:extLst>
+              <a:ext uri="{FF2B5EF4-FFF2-40B4-BE49-F238E27FC236}">
+                <a16:creationId xmlns:a16="http://schemas.microsoft.com/office/drawing/2014/main" id="{AF74B100-F150-BE1A-A13C-CBD2FCE7D19B}"/>
+              </a:ext>
+            </a:extLst>
+          </p:cNvPr>
+          <p:cNvSpPr txBox="1"/>
+          <p:nvPr/>
+        </p:nvSpPr>
+        <p:spPr>
+          <a:xfrm>
+            <a:off x="4318000" y="5499100"/>
+            <a:ext cx="3429000" cy="276999"/>
+          </a:xfrm>
+          <a:prstGeom prst="rect">
+            <a:avLst/>
+          </a:prstGeom>
+          <a:noFill/>
+        </p:spPr>
+        <p:txBody>
+          <a:bodyPr vert="horz" wrap="square" lIns="0" tIns="0" rIns="0" bIns="0" rtlCol="0">
+            <a:noAutofit/>
+          </a:bodyPr>
+          <a:lstStyle/>
+          <a:p>
+            <a:r>
+              <a:rPr lang="en-US" sz="1050" b="1">
+                <a:solidFill>
+                  <a:srgbClr val="F37021"/>
+                </a:solidFill>
+                <a:latin typeface="Arial" panose="020B0604020202020204" pitchFamily="34" charset="0"/>
+              </a:rPr>
+              <a:t>HASIL PUSH</a:t>
+            </a:r>
+          </a:p>
+        </p:txBody>
+      </p:sp>
+      <p:sp>
+        <p:nvSpPr>
+          <p:cNvPr id="34" name="TextBox 33">
+            <a:extLst>
+              <a:ext uri="{FF2B5EF4-FFF2-40B4-BE49-F238E27FC236}">
+                <a16:creationId xmlns:a16="http://schemas.microsoft.com/office/drawing/2014/main" id="{B864305D-94C1-CBA2-4912-2EC5B118054C}"/>
+              </a:ext>
+            </a:extLst>
+          </p:cNvPr>
+          <p:cNvSpPr txBox="1"/>
+          <p:nvPr/>
+        </p:nvSpPr>
+        <p:spPr>
+          <a:xfrm>
+            <a:off x="4318000" y="5727700"/>
+            <a:ext cx="3429000" cy="276999"/>
+          </a:xfrm>
+          <a:prstGeom prst="rect">
+            <a:avLst/>
+          </a:prstGeom>
+          <a:noFill/>
+        </p:spPr>
+        <p:txBody>
+          <a:bodyPr vert="horz" wrap="square" lIns="0" tIns="0" rIns="0" bIns="0" rtlCol="0">
+            <a:noAutofit/>
+          </a:bodyPr>
+          <a:lstStyle/>
+          <a:p>
+            <a:r>
+              <a:rPr lang="en-US" sz="1300">
+                <a:solidFill>
+                  <a:srgbClr val="FFFFFF"/>
+                </a:solidFill>
+                <a:latin typeface="Arial" panose="020B0604020202020204" pitchFamily="34" charset="0"/>
+              </a:rPr>
+              <a:t>SHA lokal = remote saat uji</a:t>
+            </a:r>
+          </a:p>
+        </p:txBody>
+      </p:sp>
+      <p:sp>
+        <p:nvSpPr>
+          <p:cNvPr id="35" name="TextBox 34">
+            <a:extLst>
+              <a:ext uri="{FF2B5EF4-FFF2-40B4-BE49-F238E27FC236}">
+                <a16:creationId xmlns:a16="http://schemas.microsoft.com/office/drawing/2014/main" id="{7FEE0EF9-5060-12FC-A5E6-E5367599FF83}"/>
+              </a:ext>
+            </a:extLst>
+          </p:cNvPr>
+          <p:cNvSpPr txBox="1"/>
+          <p:nvPr/>
+        </p:nvSpPr>
+        <p:spPr>
+          <a:xfrm>
+            <a:off x="8001000" y="5499100"/>
+            <a:ext cx="3429000" cy="276999"/>
+          </a:xfrm>
+          <a:prstGeom prst="rect">
+            <a:avLst/>
+          </a:prstGeom>
+          <a:noFill/>
+        </p:spPr>
+        <p:txBody>
+          <a:bodyPr vert="horz" wrap="square" lIns="0" tIns="0" rIns="0" bIns="0" rtlCol="0">
+            <a:noAutofit/>
+          </a:bodyPr>
+          <a:lstStyle/>
+          <a:p>
+            <a:r>
+              <a:rPr lang="en-US" sz="1050" b="1">
+                <a:solidFill>
+                  <a:srgbClr val="F37021"/>
+                </a:solidFill>
+                <a:latin typeface="Arial" panose="020B0604020202020204" pitchFamily="34" charset="0"/>
+              </a:rPr>
+              <a:t>MAHASISWA</a:t>
+            </a:r>
+          </a:p>
+        </p:txBody>
+      </p:sp>
+      <p:sp>
+        <p:nvSpPr>
+          <p:cNvPr id="36" name="TextBox 35">
+            <a:extLst>
+              <a:ext uri="{FF2B5EF4-FFF2-40B4-BE49-F238E27FC236}">
+                <a16:creationId xmlns:a16="http://schemas.microsoft.com/office/drawing/2014/main" id="{B7FAF8FA-E512-3BA5-B85A-15159888CAEB}"/>
+              </a:ext>
+            </a:extLst>
+          </p:cNvPr>
+          <p:cNvSpPr txBox="1"/>
+          <p:nvPr/>
+        </p:nvSpPr>
+        <p:spPr>
+          <a:xfrm>
+            <a:off x="8001000" y="5727700"/>
+            <a:ext cx="3429000" cy="276999"/>
+          </a:xfrm>
+          <a:prstGeom prst="rect">
+            <a:avLst/>
+          </a:prstGeom>
+          <a:noFill/>
+        </p:spPr>
+        <p:txBody>
+          <a:bodyPr vert="horz" wrap="square" lIns="0" tIns="0" rIns="0" bIns="0" rtlCol="0">
+            <a:noAutofit/>
+          </a:bodyPr>
+          <a:lstStyle/>
+          <a:p>
+            <a:r>
+              <a:rPr lang="en-US" sz="1300">
+                <a:solidFill>
+                  <a:srgbClr val="FFFFFF"/>
+                </a:solidFill>
+                <a:latin typeface="Arial" panose="020B0604020202020204" pitchFamily="34" charset="0"/>
+              </a:rPr>
+              <a:t>Ulangi pada repo pribadi</a:t>
+            </a:r>
+          </a:p>
+        </p:txBody>
+      </p:sp>
+      <p:pic>
+        <p:nvPicPr>
+          <p:cNvPr id="37" name="Picture 36" descr="image.png"/>
+          <p:cNvPicPr>
+            <a:picLocks noChangeAspect="1"/>
+          </p:cNvPicPr>
+          <p:nvPr/>
+        </p:nvPicPr>
+        <p:blipFill>
+          <a:blip r:embed="rId4"/>
+          <a:stretch>
+            <a:fillRect/>
+          </a:stretch>
+        </p:blipFill>
+        <p:spPr>
+          <a:xfrm>
+            <a:off x="1146439" y="1490898"/>
+            <a:ext cx="9873722" cy="3723804"/>
+          </a:xfrm>
+          <a:prstGeom prst="rect">
+            <a:avLst/>
+          </a:prstGeom>
+        </p:spPr>
+      </p:pic>
+    </p:spTree>
   </p:cSld>
   <p:clrMapOvr>
     <a:masterClrMapping/>

</xml_diff>

<commit_message>
Align Lab 02 with group project and publish revised theory/practical slides
</commit_message>
<xml_diff>
--- a/slides/LAB02_Linux_Hands_On_Final.pptx
+++ b/slides/LAB02_Linux_Hands_On_Final.pptx
@@ -2,50 +2,50 @@
 <file path=ppt/presentation.xml><?xml version="1.0" encoding="utf-8"?>
 <p:presentation xmlns:p="http://schemas.openxmlformats.org/presentationml/2006/main">
   <p:sldMasterIdLst>
-    <p:sldMasterId xmlns:r="http://schemas.openxmlformats.org/officeDocument/2006/relationships" id="2147483648" r:id="R56f6d9dc543d45c9"/>
+    <p:sldMasterId xmlns:r="http://schemas.openxmlformats.org/officeDocument/2006/relationships" id="2147483648" r:id="R9324ceed23884ec9"/>
   </p:sldMasterIdLst>
   <p:notesMasterIdLst>
-    <p:notesMasterId xmlns:r="http://schemas.openxmlformats.org/officeDocument/2006/relationships" r:id="R60dc20f7c56d41e3"/>
+    <p:notesMasterId xmlns:r="http://schemas.openxmlformats.org/officeDocument/2006/relationships" r:id="R56d1e6073cd24fe2"/>
   </p:notesMasterIdLst>
   <p:sldIdLst>
-    <p:sldId xmlns:r="http://schemas.openxmlformats.org/officeDocument/2006/relationships" id="256" r:id="R9a02fccf12254db9"/>
-    <p:sldId xmlns:r="http://schemas.openxmlformats.org/officeDocument/2006/relationships" id="257" r:id="Rd406b86ed59e48c8"/>
-    <p:sldId xmlns:r="http://schemas.openxmlformats.org/officeDocument/2006/relationships" id="258" r:id="R74c7fc30873345c9"/>
-    <p:sldId xmlns:r="http://schemas.openxmlformats.org/officeDocument/2006/relationships" id="259" r:id="R2c48c52b39764723"/>
-    <p:sldId xmlns:r="http://schemas.openxmlformats.org/officeDocument/2006/relationships" id="260" r:id="R8d52cbaf508b4845"/>
-    <p:sldId xmlns:r="http://schemas.openxmlformats.org/officeDocument/2006/relationships" id="261" r:id="Rcbbe526cdbba4313"/>
-    <p:sldId xmlns:r="http://schemas.openxmlformats.org/officeDocument/2006/relationships" id="262" r:id="Ra29fcf26885c4989"/>
-    <p:sldId xmlns:r="http://schemas.openxmlformats.org/officeDocument/2006/relationships" id="263" r:id="R2abcb1f79eef475a"/>
-    <p:sldId xmlns:r="http://schemas.openxmlformats.org/officeDocument/2006/relationships" id="264" r:id="Refdcb80acd0b412d"/>
-    <p:sldId xmlns:r="http://schemas.openxmlformats.org/officeDocument/2006/relationships" id="265" r:id="Rd40bbf67c4944cb2"/>
-    <p:sldId xmlns:r="http://schemas.openxmlformats.org/officeDocument/2006/relationships" id="266" r:id="R0f26f4d352524ec6"/>
-    <p:sldId xmlns:r="http://schemas.openxmlformats.org/officeDocument/2006/relationships" id="267" r:id="Rb66005b5b0bf4c79"/>
-    <p:sldId xmlns:r="http://schemas.openxmlformats.org/officeDocument/2006/relationships" id="268" r:id="Ra55be0e291ce4667"/>
-    <p:sldId xmlns:r="http://schemas.openxmlformats.org/officeDocument/2006/relationships" id="269" r:id="R9219e1a269024e6a"/>
-    <p:sldId xmlns:r="http://schemas.openxmlformats.org/officeDocument/2006/relationships" id="270" r:id="R0c0e980d22db4355"/>
-    <p:sldId xmlns:r="http://schemas.openxmlformats.org/officeDocument/2006/relationships" id="271" r:id="Rf5b0320d60ff478a"/>
-    <p:sldId xmlns:r="http://schemas.openxmlformats.org/officeDocument/2006/relationships" id="272" r:id="R03415dc87c644168"/>
-    <p:sldId xmlns:r="http://schemas.openxmlformats.org/officeDocument/2006/relationships" id="273" r:id="Rd182216cd6374c49"/>
-    <p:sldId xmlns:r="http://schemas.openxmlformats.org/officeDocument/2006/relationships" id="274" r:id="R39dcbcc9d8e54ea1"/>
-    <p:sldId xmlns:r="http://schemas.openxmlformats.org/officeDocument/2006/relationships" id="275" r:id="Raeeaade6e5504390"/>
-    <p:sldId xmlns:r="http://schemas.openxmlformats.org/officeDocument/2006/relationships" id="276" r:id="R019c2e91ebb74532"/>
-    <p:sldId xmlns:r="http://schemas.openxmlformats.org/officeDocument/2006/relationships" id="277" r:id="Rfc26d2fd14754041"/>
-    <p:sldId xmlns:r="http://schemas.openxmlformats.org/officeDocument/2006/relationships" id="278" r:id="R5693c2a43b6b4412"/>
-    <p:sldId xmlns:r="http://schemas.openxmlformats.org/officeDocument/2006/relationships" id="279" r:id="R88b1b91213b04192"/>
-    <p:sldId xmlns:r="http://schemas.openxmlformats.org/officeDocument/2006/relationships" id="280" r:id="R57397be36a924388"/>
-    <p:sldId xmlns:r="http://schemas.openxmlformats.org/officeDocument/2006/relationships" id="281" r:id="R23e025555b2e469c"/>
-    <p:sldId xmlns:r="http://schemas.openxmlformats.org/officeDocument/2006/relationships" id="282" r:id="Re87cc1077bba46c6"/>
-    <p:sldId xmlns:r="http://schemas.openxmlformats.org/officeDocument/2006/relationships" id="283" r:id="R834b88adec914f1c"/>
-    <p:sldId xmlns:r="http://schemas.openxmlformats.org/officeDocument/2006/relationships" id="284" r:id="R6ac3fbadac224b9a"/>
-    <p:sldId xmlns:r="http://schemas.openxmlformats.org/officeDocument/2006/relationships" id="285" r:id="R8f3c2f014afe42f9"/>
-    <p:sldId xmlns:r="http://schemas.openxmlformats.org/officeDocument/2006/relationships" id="286" r:id="R541013cd305340ab"/>
-    <p:sldId xmlns:r="http://schemas.openxmlformats.org/officeDocument/2006/relationships" id="287" r:id="R9fd17b6d5f8248ff"/>
-    <p:sldId xmlns:r="http://schemas.openxmlformats.org/officeDocument/2006/relationships" id="288" r:id="Ra07d998cf5194e2c"/>
-    <p:sldId xmlns:r="http://schemas.openxmlformats.org/officeDocument/2006/relationships" id="289" r:id="R77498db8daee4eec"/>
-    <p:sldId xmlns:r="http://schemas.openxmlformats.org/officeDocument/2006/relationships" id="290" r:id="Rd43c6021011f4dbd"/>
-    <p:sldId xmlns:r="http://schemas.openxmlformats.org/officeDocument/2006/relationships" id="291" r:id="R51f92046cc2947b6"/>
-    <p:sldId xmlns:r="http://schemas.openxmlformats.org/officeDocument/2006/relationships" id="292" r:id="Rc9d153340d8c40ae"/>
-    <p:sldId xmlns:r="http://schemas.openxmlformats.org/officeDocument/2006/relationships" id="293" r:id="R6d5de0942b504d81"/>
+    <p:sldId xmlns:r="http://schemas.openxmlformats.org/officeDocument/2006/relationships" id="256" r:id="Ra249225fb1a34e39"/>
+    <p:sldId xmlns:r="http://schemas.openxmlformats.org/officeDocument/2006/relationships" id="257" r:id="R1aa166f395fe4058"/>
+    <p:sldId xmlns:r="http://schemas.openxmlformats.org/officeDocument/2006/relationships" id="258" r:id="R98f4885881e14094"/>
+    <p:sldId xmlns:r="http://schemas.openxmlformats.org/officeDocument/2006/relationships" id="259" r:id="Ra8f3866520594910"/>
+    <p:sldId xmlns:r="http://schemas.openxmlformats.org/officeDocument/2006/relationships" id="260" r:id="R13c2068f49de4a58"/>
+    <p:sldId xmlns:r="http://schemas.openxmlformats.org/officeDocument/2006/relationships" id="261" r:id="R82f3a279fc614b2b"/>
+    <p:sldId xmlns:r="http://schemas.openxmlformats.org/officeDocument/2006/relationships" id="262" r:id="R7d5e8fee85de4763"/>
+    <p:sldId xmlns:r="http://schemas.openxmlformats.org/officeDocument/2006/relationships" id="263" r:id="R152a2098c94d4e7f"/>
+    <p:sldId xmlns:r="http://schemas.openxmlformats.org/officeDocument/2006/relationships" id="264" r:id="R6f0e6e0acf0942dd"/>
+    <p:sldId xmlns:r="http://schemas.openxmlformats.org/officeDocument/2006/relationships" id="265" r:id="Re5f990d957214e10"/>
+    <p:sldId xmlns:r="http://schemas.openxmlformats.org/officeDocument/2006/relationships" id="266" r:id="R74fe4bfdfbf34091"/>
+    <p:sldId xmlns:r="http://schemas.openxmlformats.org/officeDocument/2006/relationships" id="267" r:id="R928aea33111949ae"/>
+    <p:sldId xmlns:r="http://schemas.openxmlformats.org/officeDocument/2006/relationships" id="268" r:id="R69271f5800ec4e3f"/>
+    <p:sldId xmlns:r="http://schemas.openxmlformats.org/officeDocument/2006/relationships" id="269" r:id="R82e77bd4d00e412c"/>
+    <p:sldId xmlns:r="http://schemas.openxmlformats.org/officeDocument/2006/relationships" id="270" r:id="R34f64120155244cd"/>
+    <p:sldId xmlns:r="http://schemas.openxmlformats.org/officeDocument/2006/relationships" id="271" r:id="Rf48342c896754431"/>
+    <p:sldId xmlns:r="http://schemas.openxmlformats.org/officeDocument/2006/relationships" id="272" r:id="R3e895fc9f051493f"/>
+    <p:sldId xmlns:r="http://schemas.openxmlformats.org/officeDocument/2006/relationships" id="273" r:id="Rba0c856642e14588"/>
+    <p:sldId xmlns:r="http://schemas.openxmlformats.org/officeDocument/2006/relationships" id="274" r:id="Rd7488568edb64732"/>
+    <p:sldId xmlns:r="http://schemas.openxmlformats.org/officeDocument/2006/relationships" id="275" r:id="R84feb23490c14401"/>
+    <p:sldId xmlns:r="http://schemas.openxmlformats.org/officeDocument/2006/relationships" id="276" r:id="Rbde302ca9fb54210"/>
+    <p:sldId xmlns:r="http://schemas.openxmlformats.org/officeDocument/2006/relationships" id="277" r:id="Rc50fcaa4addc4f64"/>
+    <p:sldId xmlns:r="http://schemas.openxmlformats.org/officeDocument/2006/relationships" id="278" r:id="R2d986f4132fa4053"/>
+    <p:sldId xmlns:r="http://schemas.openxmlformats.org/officeDocument/2006/relationships" id="279" r:id="Rb47d3421985345e4"/>
+    <p:sldId xmlns:r="http://schemas.openxmlformats.org/officeDocument/2006/relationships" id="280" r:id="R95d61a4b8b17491d"/>
+    <p:sldId xmlns:r="http://schemas.openxmlformats.org/officeDocument/2006/relationships" id="281" r:id="R0120ff23c83b415f"/>
+    <p:sldId xmlns:r="http://schemas.openxmlformats.org/officeDocument/2006/relationships" id="282" r:id="R7f62d3fe6d4147ac"/>
+    <p:sldId xmlns:r="http://schemas.openxmlformats.org/officeDocument/2006/relationships" id="283" r:id="R9dcb4f9fce7f4293"/>
+    <p:sldId xmlns:r="http://schemas.openxmlformats.org/officeDocument/2006/relationships" id="284" r:id="R2f6ad6e7f89849b2"/>
+    <p:sldId xmlns:r="http://schemas.openxmlformats.org/officeDocument/2006/relationships" id="285" r:id="R3a773ae8164d4078"/>
+    <p:sldId xmlns:r="http://schemas.openxmlformats.org/officeDocument/2006/relationships" id="286" r:id="R88d09100828244c2"/>
+    <p:sldId xmlns:r="http://schemas.openxmlformats.org/officeDocument/2006/relationships" id="287" r:id="R801712b91af049f2"/>
+    <p:sldId xmlns:r="http://schemas.openxmlformats.org/officeDocument/2006/relationships" id="288" r:id="R27187123d8f44e22"/>
+    <p:sldId xmlns:r="http://schemas.openxmlformats.org/officeDocument/2006/relationships" id="289" r:id="Rd62ff32b2d4e419e"/>
+    <p:sldId xmlns:r="http://schemas.openxmlformats.org/officeDocument/2006/relationships" id="290" r:id="R562c6cd7f411456d"/>
+    <p:sldId xmlns:r="http://schemas.openxmlformats.org/officeDocument/2006/relationships" id="291" r:id="R64644bf971694f22"/>
+    <p:sldId xmlns:r="http://schemas.openxmlformats.org/officeDocument/2006/relationships" id="292" r:id="R03e72f1f60664409"/>
+    <p:sldId xmlns:r="http://schemas.openxmlformats.org/officeDocument/2006/relationships" id="293" r:id="Rf1aaab82f7f54b1b"/>
   </p:sldIdLst>
   <p:sldSz cx="12192000" cy="6858000"/>
   <p:notesSz cx="6858000" cy="9144000"/>
@@ -3092,7 +3092,7 @@
   </p:cSld>
   <p:clrMap bg1="lt1" tx1="dk1" bg2="lt2" tx2="dk2" accent1="accent1" accent2="accent2" accent3="accent3" accent4="accent4" accent5="accent5" accent6="accent6" hlink="hlink" folHlink="folHlink"/>
   <p:sldLayoutIdLst>
-    <p:sldLayoutId xmlns:r="http://schemas.openxmlformats.org/officeDocument/2006/relationships" id="2147483649" r:id="R7c878a960177407a"/>
+    <p:sldLayoutId xmlns:r="http://schemas.openxmlformats.org/officeDocument/2006/relationships" id="2147483649" r:id="R06f942cd8a724ff1"/>
   </p:sldLayoutIdLst>
   <p:hf sldNum="0" hdr="0" ftr="0" dt="0"/>
   <p:txStyles>
@@ -3645,7 +3645,7 @@
     <p:bg>
       <p:bgPr>
         <a:blipFill xmlns:a="http://schemas.openxmlformats.org/drawingml/2006/main" rotWithShape="1">
-          <a:blip xmlns:r="http://schemas.openxmlformats.org/officeDocument/2006/relationships" r:embed="R53dc379d65d34ae1">
+          <a:blip xmlns:r="http://schemas.openxmlformats.org/officeDocument/2006/relationships" r:embed="Rd74077e03508421a">
             <a:lum/>
           </a:blip>
           <a:srcRect l="0" t="0" r="0" b="0"/>
@@ -3673,7 +3673,7 @@
           <p:nvPr/>
         </p:nvPicPr>
         <p:blipFill>
-          <a:blip xmlns:r="http://schemas.openxmlformats.org/officeDocument/2006/relationships" xmlns:a="http://schemas.openxmlformats.org/drawingml/2006/main" r:embed="R68bb6d8ae0ed4fe8"/>
+          <a:blip xmlns:r="http://schemas.openxmlformats.org/officeDocument/2006/relationships" xmlns:a="http://schemas.openxmlformats.org/drawingml/2006/main" r:embed="Rfa9c8c407fdd4caa"/>
           <a:stretch xmlns:a="http://schemas.openxmlformats.org/drawingml/2006/main">
             <a:fillRect l="0" t="0" r="0" b="0"/>
           </a:stretch>
@@ -3697,7 +3697,7 @@
           <p:nvPr/>
         </p:nvPicPr>
         <p:blipFill>
-          <a:blip xmlns:r="http://schemas.openxmlformats.org/officeDocument/2006/relationships" xmlns:a="http://schemas.openxmlformats.org/drawingml/2006/main" r:embed="Reeb493804fd3432a"/>
+          <a:blip xmlns:r="http://schemas.openxmlformats.org/officeDocument/2006/relationships" xmlns:a="http://schemas.openxmlformats.org/drawingml/2006/main" r:embed="R6772c01697264082"/>
           <a:stretch xmlns:a="http://schemas.openxmlformats.org/drawingml/2006/main">
             <a:fillRect l="0" t="0" r="0" b="0"/>
           </a:stretch>
@@ -4230,7 +4230,7 @@
           <p:nvPr/>
         </p:nvPicPr>
         <p:blipFill>
-          <a:blip xmlns:r="http://schemas.openxmlformats.org/officeDocument/2006/relationships" xmlns:a="http://schemas.openxmlformats.org/drawingml/2006/main" r:embed="R91a6b367ed9943f5"/>
+          <a:blip xmlns:r="http://schemas.openxmlformats.org/officeDocument/2006/relationships" xmlns:a="http://schemas.openxmlformats.org/drawingml/2006/main" r:embed="R0b469fbcb38745cf"/>
           <a:stretch xmlns:a="http://schemas.openxmlformats.org/drawingml/2006/main">
             <a:fillRect l="0" t="0" r="0" b="0"/>
           </a:stretch>
@@ -4254,7 +4254,7 @@
           <p:nvPr/>
         </p:nvPicPr>
         <p:blipFill>
-          <a:blip xmlns:r="http://schemas.openxmlformats.org/officeDocument/2006/relationships" xmlns:a="http://schemas.openxmlformats.org/drawingml/2006/main" r:embed="Rbc4b8a9790e748e4"/>
+          <a:blip xmlns:r="http://schemas.openxmlformats.org/officeDocument/2006/relationships" xmlns:a="http://schemas.openxmlformats.org/drawingml/2006/main" r:embed="R98095e49be76481d"/>
           <a:stretch xmlns:a="http://schemas.openxmlformats.org/drawingml/2006/main">
             <a:fillRect l="0" t="0" r="0" b="0"/>
           </a:stretch>
@@ -4834,7 +4834,7 @@
           <p:nvPr/>
         </p:nvPicPr>
         <p:blipFill>
-          <a:blip xmlns:r="http://schemas.openxmlformats.org/officeDocument/2006/relationships" xmlns:a="http://schemas.openxmlformats.org/drawingml/2006/main" r:embed="Rd50efc7df51947d2"/>
+          <a:blip xmlns:r="http://schemas.openxmlformats.org/officeDocument/2006/relationships" xmlns:a="http://schemas.openxmlformats.org/drawingml/2006/main" r:embed="Rb57bccf92b6c4b22"/>
           <a:stretch xmlns:a="http://schemas.openxmlformats.org/drawingml/2006/main">
             <a:fillRect l="0" t="0" r="0" b="0"/>
           </a:stretch>
@@ -4858,7 +4858,7 @@
           <p:nvPr/>
         </p:nvPicPr>
         <p:blipFill>
-          <a:blip xmlns:r="http://schemas.openxmlformats.org/officeDocument/2006/relationships" xmlns:a="http://schemas.openxmlformats.org/drawingml/2006/main" r:embed="R8d79bf2ef4514d13"/>
+          <a:blip xmlns:r="http://schemas.openxmlformats.org/officeDocument/2006/relationships" xmlns:a="http://schemas.openxmlformats.org/drawingml/2006/main" r:embed="R603fb2789f364886"/>
           <a:stretch xmlns:a="http://schemas.openxmlformats.org/drawingml/2006/main">
             <a:fillRect l="0" t="0" r="0" b="0"/>
           </a:stretch>
@@ -7105,7 +7105,7 @@
           <p:nvPr/>
         </p:nvPicPr>
         <p:blipFill>
-          <a:blip xmlns:r="http://schemas.openxmlformats.org/officeDocument/2006/relationships" xmlns:a="http://schemas.openxmlformats.org/drawingml/2006/main" r:embed="R966d8e10966e4a56"/>
+          <a:blip xmlns:r="http://schemas.openxmlformats.org/officeDocument/2006/relationships" xmlns:a="http://schemas.openxmlformats.org/drawingml/2006/main" r:embed="R8ddef7a6c941404d"/>
           <a:stretch xmlns:a="http://schemas.openxmlformats.org/drawingml/2006/main">
             <a:fillRect l="0" t="0" r="0" b="0"/>
           </a:stretch>
@@ -7129,7 +7129,7 @@
           <p:nvPr/>
         </p:nvPicPr>
         <p:blipFill>
-          <a:blip xmlns:r="http://schemas.openxmlformats.org/officeDocument/2006/relationships" xmlns:a="http://schemas.openxmlformats.org/drawingml/2006/main" r:embed="R39d3d9a7fb994957"/>
+          <a:blip xmlns:r="http://schemas.openxmlformats.org/officeDocument/2006/relationships" xmlns:a="http://schemas.openxmlformats.org/drawingml/2006/main" r:embed="Rd055ce19f1934244"/>
           <a:stretch xmlns:a="http://schemas.openxmlformats.org/drawingml/2006/main">
             <a:fillRect l="0" t="0" r="0" b="0"/>
           </a:stretch>
@@ -7495,7 +7495,7 @@
           <p:nvPr/>
         </p:nvPicPr>
         <p:blipFill>
-          <a:blip xmlns:r="http://schemas.openxmlformats.org/officeDocument/2006/relationships" xmlns:a="http://schemas.openxmlformats.org/drawingml/2006/main" r:embed="R6ed53784946a4994"/>
+          <a:blip xmlns:r="http://schemas.openxmlformats.org/officeDocument/2006/relationships" xmlns:a="http://schemas.openxmlformats.org/drawingml/2006/main" r:embed="R2226a7f5664147c1"/>
           <a:stretch xmlns:a="http://schemas.openxmlformats.org/drawingml/2006/main">
             <a:fillRect l="0" t="0" r="0" b="0"/>
           </a:stretch>
@@ -7519,7 +7519,7 @@
           <p:nvPr/>
         </p:nvPicPr>
         <p:blipFill>
-          <a:blip xmlns:r="http://schemas.openxmlformats.org/officeDocument/2006/relationships" xmlns:a="http://schemas.openxmlformats.org/drawingml/2006/main" r:embed="Rf8e1965e8aa94530"/>
+          <a:blip xmlns:r="http://schemas.openxmlformats.org/officeDocument/2006/relationships" xmlns:a="http://schemas.openxmlformats.org/drawingml/2006/main" r:embed="R85d2a4ba0b0841da"/>
           <a:stretch xmlns:a="http://schemas.openxmlformats.org/drawingml/2006/main">
             <a:fillRect l="0" t="0" r="0" b="0"/>
           </a:stretch>
@@ -9491,7 +9491,7 @@
           <p:nvPr/>
         </p:nvPicPr>
         <p:blipFill>
-          <a:blip xmlns:r="http://schemas.openxmlformats.org/officeDocument/2006/relationships" xmlns:a="http://schemas.openxmlformats.org/drawingml/2006/main" r:embed="Radc201e8ec22410d"/>
+          <a:blip xmlns:r="http://schemas.openxmlformats.org/officeDocument/2006/relationships" xmlns:a="http://schemas.openxmlformats.org/drawingml/2006/main" r:embed="Rf4c2f561d9e848fb"/>
           <a:stretch xmlns:a="http://schemas.openxmlformats.org/drawingml/2006/main">
             <a:fillRect l="0" t="0" r="0" b="0"/>
           </a:stretch>
@@ -9515,7 +9515,7 @@
           <p:nvPr/>
         </p:nvPicPr>
         <p:blipFill>
-          <a:blip xmlns:r="http://schemas.openxmlformats.org/officeDocument/2006/relationships" xmlns:a="http://schemas.openxmlformats.org/drawingml/2006/main" r:embed="R84f7ec6da196485f"/>
+          <a:blip xmlns:r="http://schemas.openxmlformats.org/officeDocument/2006/relationships" xmlns:a="http://schemas.openxmlformats.org/drawingml/2006/main" r:embed="R5eac38f8b18d42cf"/>
           <a:stretch xmlns:a="http://schemas.openxmlformats.org/drawingml/2006/main">
             <a:fillRect l="0" t="0" r="0" b="0"/>
           </a:stretch>
@@ -11588,7 +11588,7 @@
           <p:nvPr/>
         </p:nvPicPr>
         <p:blipFill>
-          <a:blip xmlns:r="http://schemas.openxmlformats.org/officeDocument/2006/relationships" xmlns:a="http://schemas.openxmlformats.org/drawingml/2006/main" r:embed="Rfaa18656039e4e92"/>
+          <a:blip xmlns:r="http://schemas.openxmlformats.org/officeDocument/2006/relationships" xmlns:a="http://schemas.openxmlformats.org/drawingml/2006/main" r:embed="Re3bc92d8709140bc"/>
           <a:stretch xmlns:a="http://schemas.openxmlformats.org/drawingml/2006/main">
             <a:fillRect l="0" t="0" r="0" b="0"/>
           </a:stretch>
@@ -11989,7 +11989,7 @@
           <p:nvPr/>
         </p:nvPicPr>
         <p:blipFill>
-          <a:blip xmlns:r="http://schemas.openxmlformats.org/officeDocument/2006/relationships" xmlns:a="http://schemas.openxmlformats.org/drawingml/2006/main" r:embed="R770c9cd1594f43f4"/>
+          <a:blip xmlns:r="http://schemas.openxmlformats.org/officeDocument/2006/relationships" xmlns:a="http://schemas.openxmlformats.org/drawingml/2006/main" r:embed="R81d12f9911574ddf"/>
           <a:stretch xmlns:a="http://schemas.openxmlformats.org/drawingml/2006/main">
             <a:fillRect l="0" t="0" r="0" b="0"/>
           </a:stretch>
@@ -12013,7 +12013,7 @@
           <p:nvPr/>
         </p:nvPicPr>
         <p:blipFill>
-          <a:blip xmlns:r="http://schemas.openxmlformats.org/officeDocument/2006/relationships" xmlns:a="http://schemas.openxmlformats.org/drawingml/2006/main" r:embed="Ra47f6cdc1fe94f2e"/>
+          <a:blip xmlns:r="http://schemas.openxmlformats.org/officeDocument/2006/relationships" xmlns:a="http://schemas.openxmlformats.org/drawingml/2006/main" r:embed="R3e9de59674274333"/>
           <a:stretch xmlns:a="http://schemas.openxmlformats.org/drawingml/2006/main">
             <a:fillRect l="0" t="0" r="0" b="0"/>
           </a:stretch>
@@ -12379,7 +12379,7 @@
           <p:nvPr/>
         </p:nvPicPr>
         <p:blipFill>
-          <a:blip xmlns:r="http://schemas.openxmlformats.org/officeDocument/2006/relationships" xmlns:a="http://schemas.openxmlformats.org/drawingml/2006/main" r:embed="R55aaa6354f4b4577"/>
+          <a:blip xmlns:r="http://schemas.openxmlformats.org/officeDocument/2006/relationships" xmlns:a="http://schemas.openxmlformats.org/drawingml/2006/main" r:embed="R51b50324010e45f3"/>
           <a:stretch xmlns:a="http://schemas.openxmlformats.org/drawingml/2006/main">
             <a:fillRect l="0" t="0" r="0" b="0"/>
           </a:stretch>
@@ -12403,7 +12403,7 @@
           <p:nvPr/>
         </p:nvPicPr>
         <p:blipFill>
-          <a:blip xmlns:r="http://schemas.openxmlformats.org/officeDocument/2006/relationships" xmlns:a="http://schemas.openxmlformats.org/drawingml/2006/main" r:embed="R045fc2bb20ec4da6"/>
+          <a:blip xmlns:r="http://schemas.openxmlformats.org/officeDocument/2006/relationships" xmlns:a="http://schemas.openxmlformats.org/drawingml/2006/main" r:embed="Rd9f33770c3f145ea"/>
           <a:stretch xmlns:a="http://schemas.openxmlformats.org/drawingml/2006/main">
             <a:fillRect l="0" t="0" r="0" b="0"/>
           </a:stretch>
@@ -14137,7 +14137,7 @@
           <p:nvPr/>
         </p:nvPicPr>
         <p:blipFill>
-          <a:blip xmlns:r="http://schemas.openxmlformats.org/officeDocument/2006/relationships" xmlns:a="http://schemas.openxmlformats.org/drawingml/2006/main" r:embed="R9bed0b0b49f14dad"/>
+          <a:blip xmlns:r="http://schemas.openxmlformats.org/officeDocument/2006/relationships" xmlns:a="http://schemas.openxmlformats.org/drawingml/2006/main" r:embed="Re75ae4c956ef4328"/>
           <a:stretch xmlns:a="http://schemas.openxmlformats.org/drawingml/2006/main">
             <a:fillRect l="0" t="0" r="0" b="0"/>
           </a:stretch>
@@ -14161,7 +14161,7 @@
           <p:nvPr/>
         </p:nvPicPr>
         <p:blipFill>
-          <a:blip xmlns:r="http://schemas.openxmlformats.org/officeDocument/2006/relationships" xmlns:a="http://schemas.openxmlformats.org/drawingml/2006/main" r:embed="R9bcb895400a1490d"/>
+          <a:blip xmlns:r="http://schemas.openxmlformats.org/officeDocument/2006/relationships" xmlns:a="http://schemas.openxmlformats.org/drawingml/2006/main" r:embed="Rff992008593a46fe"/>
           <a:stretch xmlns:a="http://schemas.openxmlformats.org/drawingml/2006/main">
             <a:fillRect l="0" t="0" r="0" b="0"/>
           </a:stretch>
@@ -15367,7 +15367,7 @@
           <p:nvPr/>
         </p:nvPicPr>
         <p:blipFill>
-          <a:blip xmlns:r="http://schemas.openxmlformats.org/officeDocument/2006/relationships" xmlns:a="http://schemas.openxmlformats.org/drawingml/2006/main" r:embed="Rfe2b91851e2449ab"/>
+          <a:blip xmlns:r="http://schemas.openxmlformats.org/officeDocument/2006/relationships" xmlns:a="http://schemas.openxmlformats.org/drawingml/2006/main" r:embed="Rc455652cc07d4a5b"/>
           <a:stretch xmlns:a="http://schemas.openxmlformats.org/drawingml/2006/main">
             <a:fillRect l="0" t="0" r="0" b="0"/>
           </a:stretch>
@@ -15391,7 +15391,7 @@
           <p:nvPr/>
         </p:nvPicPr>
         <p:blipFill>
-          <a:blip xmlns:r="http://schemas.openxmlformats.org/officeDocument/2006/relationships" xmlns:a="http://schemas.openxmlformats.org/drawingml/2006/main" r:embed="R69f6c2566a9c4670"/>
+          <a:blip xmlns:r="http://schemas.openxmlformats.org/officeDocument/2006/relationships" xmlns:a="http://schemas.openxmlformats.org/drawingml/2006/main" r:embed="R4f52c1149eb04200"/>
           <a:stretch xmlns:a="http://schemas.openxmlformats.org/drawingml/2006/main">
             <a:fillRect l="0" t="0" r="0" b="0"/>
           </a:stretch>
@@ -15757,7 +15757,7 @@
           <p:nvPr/>
         </p:nvPicPr>
         <p:blipFill>
-          <a:blip xmlns:r="http://schemas.openxmlformats.org/officeDocument/2006/relationships" xmlns:a="http://schemas.openxmlformats.org/drawingml/2006/main" r:embed="Rb467479520d94020"/>
+          <a:blip xmlns:r="http://schemas.openxmlformats.org/officeDocument/2006/relationships" xmlns:a="http://schemas.openxmlformats.org/drawingml/2006/main" r:embed="R6dc5716b99d946ec"/>
           <a:stretch xmlns:a="http://schemas.openxmlformats.org/drawingml/2006/main">
             <a:fillRect l="0" t="0" r="0" b="0"/>
           </a:stretch>
@@ -15781,7 +15781,7 @@
           <p:nvPr/>
         </p:nvPicPr>
         <p:blipFill>
-          <a:blip xmlns:r="http://schemas.openxmlformats.org/officeDocument/2006/relationships" xmlns:a="http://schemas.openxmlformats.org/drawingml/2006/main" r:embed="R995d01c176864457"/>
+          <a:blip xmlns:r="http://schemas.openxmlformats.org/officeDocument/2006/relationships" xmlns:a="http://schemas.openxmlformats.org/drawingml/2006/main" r:embed="R83111acdfefa4ff8"/>
           <a:stretch xmlns:a="http://schemas.openxmlformats.org/drawingml/2006/main">
             <a:fillRect l="0" t="0" r="0" b="0"/>
           </a:stretch>
@@ -16635,7 +16635,7 @@
           <p:nvPr/>
         </p:nvPicPr>
         <p:blipFill>
-          <a:blip xmlns:r="http://schemas.openxmlformats.org/officeDocument/2006/relationships" xmlns:a="http://schemas.openxmlformats.org/drawingml/2006/main" r:embed="Rc5723956a1314ea8"/>
+          <a:blip xmlns:r="http://schemas.openxmlformats.org/officeDocument/2006/relationships" xmlns:a="http://schemas.openxmlformats.org/drawingml/2006/main" r:embed="Ra8ba7b6d2b944ace"/>
           <a:stretch xmlns:a="http://schemas.openxmlformats.org/drawingml/2006/main">
             <a:fillRect l="0" t="0" r="0" b="0"/>
           </a:stretch>
@@ -16659,7 +16659,7 @@
           <p:nvPr/>
         </p:nvPicPr>
         <p:blipFill>
-          <a:blip xmlns:r="http://schemas.openxmlformats.org/officeDocument/2006/relationships" xmlns:a="http://schemas.openxmlformats.org/drawingml/2006/main" r:embed="R527c27da32804da6"/>
+          <a:blip xmlns:r="http://schemas.openxmlformats.org/officeDocument/2006/relationships" xmlns:a="http://schemas.openxmlformats.org/drawingml/2006/main" r:embed="R0af0e4ed95874ccc"/>
           <a:stretch xmlns:a="http://schemas.openxmlformats.org/drawingml/2006/main">
             <a:fillRect l="0" t="0" r="0" b="0"/>
           </a:stretch>
@@ -16791,7 +16791,7 @@
                 <a:ea typeface="Calibri"/>
                 <a:cs typeface="Calibri"/>
               </a:rPr>
-              <a:t>Teori Linux umum; tugas inti pada slide 32-36 dan modul repo</a:t>
+              <a:t>Teori Linux umum; latihan inti pada slide 32-36 dan modul repo</a:t>
             </a:r>
             <a:endParaRPr sz="1200"/>
           </a:p>
@@ -16919,7 +16919,7 @@
           <p:nvPr/>
         </p:nvPicPr>
         <p:blipFill>
-          <a:blip xmlns:r="http://schemas.openxmlformats.org/officeDocument/2006/relationships" xmlns:a="http://schemas.openxmlformats.org/drawingml/2006/main" r:embed="R217763b5e3e246a8"/>
+          <a:blip xmlns:r="http://schemas.openxmlformats.org/officeDocument/2006/relationships" xmlns:a="http://schemas.openxmlformats.org/drawingml/2006/main" r:embed="R6b0e7497f6254623"/>
           <a:stretch xmlns:a="http://schemas.openxmlformats.org/drawingml/2006/main">
             <a:fillRect l="0" t="0" r="0" b="0"/>
           </a:stretch>
@@ -16989,7 +16989,7 @@
           <p:nvPr/>
         </p:nvPicPr>
         <p:blipFill>
-          <a:blip xmlns:r="http://schemas.openxmlformats.org/officeDocument/2006/relationships" xmlns:a="http://schemas.openxmlformats.org/drawingml/2006/main" r:embed="Rd2100479d44c4529"/>
+          <a:blip xmlns:r="http://schemas.openxmlformats.org/officeDocument/2006/relationships" xmlns:a="http://schemas.openxmlformats.org/drawingml/2006/main" r:embed="R025195502c954018"/>
           <a:stretch xmlns:a="http://schemas.openxmlformats.org/drawingml/2006/main">
             <a:fillRect l="0" t="0" r="0" b="0"/>
           </a:stretch>
@@ -17059,7 +17059,7 @@
           <p:nvPr/>
         </p:nvPicPr>
         <p:blipFill>
-          <a:blip xmlns:r="http://schemas.openxmlformats.org/officeDocument/2006/relationships" xmlns:a="http://schemas.openxmlformats.org/drawingml/2006/main" r:embed="R8537eee7fd814416"/>
+          <a:blip xmlns:r="http://schemas.openxmlformats.org/officeDocument/2006/relationships" xmlns:a="http://schemas.openxmlformats.org/drawingml/2006/main" r:embed="Re2429f605f594e89"/>
           <a:stretch xmlns:a="http://schemas.openxmlformats.org/drawingml/2006/main">
             <a:fillRect l="0" t="0" r="0" b="0"/>
           </a:stretch>
@@ -17129,7 +17129,7 @@
           <p:nvPr/>
         </p:nvPicPr>
         <p:blipFill>
-          <a:blip xmlns:r="http://schemas.openxmlformats.org/officeDocument/2006/relationships" xmlns:a="http://schemas.openxmlformats.org/drawingml/2006/main" r:embed="R2aa64ea4a73f49bb"/>
+          <a:blip xmlns:r="http://schemas.openxmlformats.org/officeDocument/2006/relationships" xmlns:a="http://schemas.openxmlformats.org/drawingml/2006/main" r:embed="Ra0cfbf0e525342e1"/>
           <a:stretch xmlns:a="http://schemas.openxmlformats.org/drawingml/2006/main">
             <a:fillRect l="0" t="0" r="0" b="0"/>
           </a:stretch>
@@ -17199,7 +17199,7 @@
           <p:nvPr/>
         </p:nvPicPr>
         <p:blipFill>
-          <a:blip xmlns:r="http://schemas.openxmlformats.org/officeDocument/2006/relationships" xmlns:a="http://schemas.openxmlformats.org/drawingml/2006/main" r:embed="R0c34f41a36554028"/>
+          <a:blip xmlns:r="http://schemas.openxmlformats.org/officeDocument/2006/relationships" xmlns:a="http://schemas.openxmlformats.org/drawingml/2006/main" r:embed="R47dda47fd7f24919"/>
           <a:stretch xmlns:a="http://schemas.openxmlformats.org/drawingml/2006/main">
             <a:fillRect l="0" t="0" r="0" b="0"/>
           </a:stretch>
@@ -17269,7 +17269,7 @@
           <p:nvPr/>
         </p:nvPicPr>
         <p:blipFill>
-          <a:blip xmlns:r="http://schemas.openxmlformats.org/officeDocument/2006/relationships" xmlns:a="http://schemas.openxmlformats.org/drawingml/2006/main" r:embed="R6ea65a16e94044bd"/>
+          <a:blip xmlns:r="http://schemas.openxmlformats.org/officeDocument/2006/relationships" xmlns:a="http://schemas.openxmlformats.org/drawingml/2006/main" r:embed="R485bbd6adfdd4717"/>
           <a:stretch xmlns:a="http://schemas.openxmlformats.org/drawingml/2006/main">
             <a:fillRect l="0" t="0" r="0" b="0"/>
           </a:stretch>
@@ -17403,7 +17403,7 @@
                 <a:ea typeface="Calibri"/>
                 <a:cs typeface="Calibri"/>
               </a:rPr>
-              <a:t>DELIVERABLES</a:t>
+              <a:t>KONTRIBUSI KE PROYEK</a:t>
             </a:r>
             <a:endParaRPr sz="1100"/>
           </a:p>
@@ -17437,7 +17437,7 @@
                 <a:ea typeface="Calibri"/>
                 <a:cs typeface="Calibri"/>
               </a:rPr>
-              <a:t>Yang Dikumpul</a:t>
+              <a:t>Bukti teknik Linux</a:t>
             </a:r>
             <a:endParaRPr sz="1100"/>
           </a:p>
@@ -17486,11 +17486,55 @@
                 <a:ea typeface="Calibri"/>
                 <a:cs typeface="Calibri"/>
               </a:rPr>
-              <a:t>1. URL repo pribadi meet2CloudService
-2. workspace/ berisi lima artefak tugas
-3. check-status.sh dan Hasil: 0 gagal
-4. hasil/lab02.md dan bukti screenshot
-5. Jawaban lima pertanyaan modul mahasiswa</a:t>
+              <a:t>Path dan permission untuk source proyek</a:t>
+            </a:r>
+            <a:br/>
+            <a:r>
+              <a:rPr sz="1200">
+                <a:solidFill>
+                  <a:srgbClr val="FFFFFF"/>
+                </a:solidFill>
+                <a:latin typeface="Calibri"/>
+                <a:ea typeface="Calibri"/>
+                <a:cs typeface="Calibri"/>
+              </a:rPr>
+              <a:t>Bash untuk setup dan pemeriksaan</a:t>
+            </a:r>
+            <a:br/>
+            <a:r>
+              <a:rPr sz="1200">
+                <a:solidFill>
+                  <a:srgbClr val="FFFFFF"/>
+                </a:solidFill>
+                <a:latin typeface="Calibri"/>
+                <a:ea typeface="Calibri"/>
+                <a:cs typeface="Calibri"/>
+              </a:rPr>
+              <a:t>Catatan opsional; tidak ada submit Lab 02</a:t>
+            </a:r>
+            <a:br/>
+            <a:r>
+              <a:rPr sz="1200">
+                <a:solidFill>
+                  <a:srgbClr val="FFFFFF"/>
+                </a:solidFill>
+                <a:latin typeface="Calibri"/>
+                <a:ea typeface="Calibri"/>
+                <a:cs typeface="Calibri"/>
+              </a:rPr>
+              <a:t> </a:t>
+            </a:r>
+            <a:br/>
+            <a:r>
+              <a:rPr sz="1200">
+                <a:solidFill>
+                  <a:srgbClr val="FFFFFF"/>
+                </a:solidFill>
+                <a:latin typeface="Calibri"/>
+                <a:ea typeface="Calibri"/>
+                <a:cs typeface="Calibri"/>
+              </a:rPr>
+              <a:t> </a:t>
             </a:r>
             <a:endParaRPr sz="1200"/>
           </a:p>
@@ -17569,7 +17613,7 @@
                 <a:ea typeface="Calibri"/>
                 <a:cs typeface="Calibri"/>
               </a:rPr>
-              <a:t>Waktu kumpul mengikuti LMS/dosen</a:t>
+              <a:t>Proyek 3 orang: checkpoint minggu 7, final minggu 14</a:t>
             </a:r>
             <a:endParaRPr sz="1200"/>
           </a:p>
@@ -17738,7 +17782,7 @@
           <p:nvPr/>
         </p:nvPicPr>
         <p:blipFill>
-          <a:blip xmlns:r="http://schemas.openxmlformats.org/officeDocument/2006/relationships" xmlns:a="http://schemas.openxmlformats.org/drawingml/2006/main" r:embed="Raff41419fbe04358"/>
+          <a:blip xmlns:r="http://schemas.openxmlformats.org/officeDocument/2006/relationships" xmlns:a="http://schemas.openxmlformats.org/drawingml/2006/main" r:embed="Rcbd6045c747647e8"/>
           <a:stretch xmlns:a="http://schemas.openxmlformats.org/drawingml/2006/main">
             <a:fillRect l="0" t="0" r="0" b="0"/>
           </a:stretch>
@@ -17762,7 +17806,7 @@
           <p:nvPr/>
         </p:nvPicPr>
         <p:blipFill>
-          <a:blip xmlns:r="http://schemas.openxmlformats.org/officeDocument/2006/relationships" xmlns:a="http://schemas.openxmlformats.org/drawingml/2006/main" r:embed="R81b8f53bb0aa4ce1"/>
+          <a:blip xmlns:r="http://schemas.openxmlformats.org/officeDocument/2006/relationships" xmlns:a="http://schemas.openxmlformats.org/drawingml/2006/main" r:embed="R96b864c9a07c4d5d"/>
           <a:stretch xmlns:a="http://schemas.openxmlformats.org/drawingml/2006/main">
             <a:fillRect l="0" t="0" r="0" b="0"/>
           </a:stretch>
@@ -18456,7 +18500,7 @@
           <p:nvPr/>
         </p:nvPicPr>
         <p:blipFill>
-          <a:blip xmlns:r="http://schemas.openxmlformats.org/officeDocument/2006/relationships" xmlns:a="http://schemas.openxmlformats.org/drawingml/2006/main" r:embed="Rdf74cc79a83a4398"/>
+          <a:blip xmlns:r="http://schemas.openxmlformats.org/officeDocument/2006/relationships" xmlns:a="http://schemas.openxmlformats.org/drawingml/2006/main" r:embed="Rc7a3a00b73a74bca"/>
           <a:stretch xmlns:a="http://schemas.openxmlformats.org/drawingml/2006/main">
             <a:fillRect l="0" t="0" r="0" b="0"/>
           </a:stretch>
@@ -18480,7 +18524,7 @@
           <p:nvPr/>
         </p:nvPicPr>
         <p:blipFill>
-          <a:blip xmlns:r="http://schemas.openxmlformats.org/officeDocument/2006/relationships" xmlns:a="http://schemas.openxmlformats.org/drawingml/2006/main" r:embed="R569de2d42a744875"/>
+          <a:blip xmlns:r="http://schemas.openxmlformats.org/officeDocument/2006/relationships" xmlns:a="http://schemas.openxmlformats.org/drawingml/2006/main" r:embed="Raca5e23dbca7484f"/>
           <a:stretch xmlns:a="http://schemas.openxmlformats.org/drawingml/2006/main">
             <a:fillRect l="0" t="0" r="0" b="0"/>
           </a:stretch>
@@ -18846,7 +18890,7 @@
           <p:nvPr/>
         </p:nvPicPr>
         <p:blipFill>
-          <a:blip xmlns:r="http://schemas.openxmlformats.org/officeDocument/2006/relationships" xmlns:a="http://schemas.openxmlformats.org/drawingml/2006/main" r:embed="R1114263d3304423d"/>
+          <a:blip xmlns:r="http://schemas.openxmlformats.org/officeDocument/2006/relationships" xmlns:a="http://schemas.openxmlformats.org/drawingml/2006/main" r:embed="R7169c68d5a774697"/>
           <a:stretch xmlns:a="http://schemas.openxmlformats.org/drawingml/2006/main">
             <a:fillRect l="0" t="0" r="0" b="0"/>
           </a:stretch>
@@ -18870,7 +18914,7 @@
           <p:nvPr/>
         </p:nvPicPr>
         <p:blipFill>
-          <a:blip xmlns:r="http://schemas.openxmlformats.org/officeDocument/2006/relationships" xmlns:a="http://schemas.openxmlformats.org/drawingml/2006/main" r:embed="Re33dd06105074cd0"/>
+          <a:blip xmlns:r="http://schemas.openxmlformats.org/officeDocument/2006/relationships" xmlns:a="http://schemas.openxmlformats.org/drawingml/2006/main" r:embed="Raab10ec6000047b6"/>
           <a:stretch xmlns:a="http://schemas.openxmlformats.org/drawingml/2006/main">
             <a:fillRect l="0" t="0" r="0" b="0"/>
           </a:stretch>
@@ -20458,7 +20502,7 @@
           <p:nvPr/>
         </p:nvPicPr>
         <p:blipFill>
-          <a:blip xmlns:r="http://schemas.openxmlformats.org/officeDocument/2006/relationships" xmlns:a="http://schemas.openxmlformats.org/drawingml/2006/main" r:embed="Rf389f55230e24372"/>
+          <a:blip xmlns:r="http://schemas.openxmlformats.org/officeDocument/2006/relationships" xmlns:a="http://schemas.openxmlformats.org/drawingml/2006/main" r:embed="R4b89f005c74a4acf"/>
           <a:stretch xmlns:a="http://schemas.openxmlformats.org/drawingml/2006/main">
             <a:fillRect l="0" t="0" r="0" b="0"/>
           </a:stretch>
@@ -20482,7 +20526,7 @@
           <p:nvPr/>
         </p:nvPicPr>
         <p:blipFill>
-          <a:blip xmlns:r="http://schemas.openxmlformats.org/officeDocument/2006/relationships" xmlns:a="http://schemas.openxmlformats.org/drawingml/2006/main" r:embed="R54a34ddab70d4427"/>
+          <a:blip xmlns:r="http://schemas.openxmlformats.org/officeDocument/2006/relationships" xmlns:a="http://schemas.openxmlformats.org/drawingml/2006/main" r:embed="Rd5b6915348ef49cd"/>
           <a:stretch xmlns:a="http://schemas.openxmlformats.org/drawingml/2006/main">
             <a:fillRect l="0" t="0" r="0" b="0"/>
           </a:stretch>
@@ -22348,7 +22392,7 @@
           <p:nvPr/>
         </p:nvPicPr>
         <p:blipFill>
-          <a:blip xmlns:r="http://schemas.openxmlformats.org/officeDocument/2006/relationships" xmlns:a="http://schemas.openxmlformats.org/drawingml/2006/main" r:embed="R9e3b16d8d88342af"/>
+          <a:blip xmlns:r="http://schemas.openxmlformats.org/officeDocument/2006/relationships" xmlns:a="http://schemas.openxmlformats.org/drawingml/2006/main" r:embed="Rc1ee5b4f5d934d47"/>
           <a:stretch xmlns:a="http://schemas.openxmlformats.org/drawingml/2006/main">
             <a:fillRect l="0" t="0" r="0" b="0"/>
           </a:stretch>
@@ -22372,7 +22416,7 @@
           <p:nvPr/>
         </p:nvPicPr>
         <p:blipFill>
-          <a:blip xmlns:r="http://schemas.openxmlformats.org/officeDocument/2006/relationships" xmlns:a="http://schemas.openxmlformats.org/drawingml/2006/main" r:embed="Rd160573c366f41e4"/>
+          <a:blip xmlns:r="http://schemas.openxmlformats.org/officeDocument/2006/relationships" xmlns:a="http://schemas.openxmlformats.org/drawingml/2006/main" r:embed="R74f18c542c3c482c"/>
           <a:stretch xmlns:a="http://schemas.openxmlformats.org/drawingml/2006/main">
             <a:fillRect l="0" t="0" r="0" b="0"/>
           </a:stretch>
@@ -22473,7 +22517,7 @@
                 <a:ea typeface="Calibri"/>
                 <a:cs typeface="Calibri"/>
               </a:rPr>
-              <a:t>Mini Project</a:t>
+              <a:t>Latihan Skrip</a:t>
             </a:r>
             <a:endParaRPr sz="5200"/>
           </a:p>
@@ -22490,7 +22534,7 @@
                 <a:ea typeface="Calibri"/>
                 <a:cs typeface="Calibri"/>
               </a:rPr>
-              <a:t>&amp; Submission</a:t>
+              <a:t>&amp; Verifikasi</a:t>
             </a:r>
             <a:endParaRPr sz="5200"/>
           </a:p>
@@ -22569,7 +22613,7 @@
                 <a:ea typeface="Calibri"/>
                 <a:cs typeface="Calibri"/>
               </a:rPr>
-              <a:t>Tugas inti memakai check-status.sh dan verifier dari repo Lab 02.</a:t>
+              <a:t>Praktik memakai check-status.sh dan verifier dari repo Lab 02.</a:t>
             </a:r>
             <a:endParaRPr sz="1400"/>
           </a:p>
@@ -22738,7 +22782,7 @@
           <p:nvPr/>
         </p:nvPicPr>
         <p:blipFill>
-          <a:blip xmlns:r="http://schemas.openxmlformats.org/officeDocument/2006/relationships" xmlns:a="http://schemas.openxmlformats.org/drawingml/2006/main" r:embed="R5730155100b64729"/>
+          <a:blip xmlns:r="http://schemas.openxmlformats.org/officeDocument/2006/relationships" xmlns:a="http://schemas.openxmlformats.org/drawingml/2006/main" r:embed="Re59be6aedf6e4c94"/>
           <a:stretch xmlns:a="http://schemas.openxmlformats.org/drawingml/2006/main">
             <a:fillRect l="0" t="0" r="0" b="0"/>
           </a:stretch>
@@ -22762,7 +22806,7 @@
           <p:nvPr/>
         </p:nvPicPr>
         <p:blipFill>
-          <a:blip xmlns:r="http://schemas.openxmlformats.org/officeDocument/2006/relationships" xmlns:a="http://schemas.openxmlformats.org/drawingml/2006/main" r:embed="Rb38d0ca317584ed4"/>
+          <a:blip xmlns:r="http://schemas.openxmlformats.org/officeDocument/2006/relationships" xmlns:a="http://schemas.openxmlformats.org/drawingml/2006/main" r:embed="Rd59e8275bc1b48ae"/>
           <a:stretch xmlns:a="http://schemas.openxmlformats.org/drawingml/2006/main">
             <a:fillRect l="0" t="0" r="0" b="0"/>
           </a:stretch>
@@ -23345,7 +23389,7 @@
           <p:nvPr/>
         </p:nvPicPr>
         <p:blipFill>
-          <a:blip xmlns:r="http://schemas.openxmlformats.org/officeDocument/2006/relationships" xmlns:a="http://schemas.openxmlformats.org/drawingml/2006/main" r:embed="Rc982ea5520144ad4"/>
+          <a:blip xmlns:r="http://schemas.openxmlformats.org/officeDocument/2006/relationships" xmlns:a="http://schemas.openxmlformats.org/drawingml/2006/main" r:embed="R6f31b2c06f2d4702"/>
           <a:stretch xmlns:a="http://schemas.openxmlformats.org/drawingml/2006/main">
             <a:fillRect l="0" t="0" r="0" b="0"/>
           </a:stretch>
@@ -23369,7 +23413,7 @@
           <p:nvPr/>
         </p:nvPicPr>
         <p:blipFill>
-          <a:blip xmlns:r="http://schemas.openxmlformats.org/officeDocument/2006/relationships" xmlns:a="http://schemas.openxmlformats.org/drawingml/2006/main" r:embed="R86d5a74db9b34616"/>
+          <a:blip xmlns:r="http://schemas.openxmlformats.org/officeDocument/2006/relationships" xmlns:a="http://schemas.openxmlformats.org/drawingml/2006/main" r:embed="R9ba37e8c3aa44db3"/>
           <a:stretch xmlns:a="http://schemas.openxmlformats.org/drawingml/2006/main">
             <a:fillRect l="0" t="0" r="0" b="0"/>
           </a:stretch>
@@ -24426,7 +24470,7 @@
           <p:nvPr/>
         </p:nvPicPr>
         <p:blipFill>
-          <a:blip xmlns:r="http://schemas.openxmlformats.org/officeDocument/2006/relationships" xmlns:a="http://schemas.openxmlformats.org/drawingml/2006/main" r:embed="Rcfb3ab9ab6df4053"/>
+          <a:blip xmlns:r="http://schemas.openxmlformats.org/officeDocument/2006/relationships" xmlns:a="http://schemas.openxmlformats.org/drawingml/2006/main" r:embed="R849411db94ff4f24"/>
           <a:stretch xmlns:a="http://schemas.openxmlformats.org/drawingml/2006/main">
             <a:fillRect l="0" t="0" r="0" b="0"/>
           </a:stretch>
@@ -24450,7 +24494,7 @@
           <p:nvPr/>
         </p:nvPicPr>
         <p:blipFill>
-          <a:blip xmlns:r="http://schemas.openxmlformats.org/officeDocument/2006/relationships" xmlns:a="http://schemas.openxmlformats.org/drawingml/2006/main" r:embed="R55c2941b1ae040d0"/>
+          <a:blip xmlns:r="http://schemas.openxmlformats.org/officeDocument/2006/relationships" xmlns:a="http://schemas.openxmlformats.org/drawingml/2006/main" r:embed="Ree28522584564daf"/>
           <a:stretch xmlns:a="http://schemas.openxmlformats.org/drawingml/2006/main">
             <a:fillRect l="0" t="0" r="0" b="0"/>
           </a:stretch>
@@ -24536,7 +24580,7 @@
                 <a:ea typeface="Calibri"/>
                 <a:cs typeface="Calibri"/>
               </a:rPr>
-              <a:t>Checklist formatif Praktikum 2</a:t>
+              <a:t>Cek formatif Praktikum 2</a:t>
             </a:r>
             <a:endParaRPr sz="2200"/>
           </a:p>
@@ -24582,7 +24626,7 @@
                 <a:ea typeface="Calibri"/>
                 <a:cs typeface="Calibri"/>
               </a:rPr>
-              <a:t>Contoh pembobotan; dosen dapat menyesuaikan dengan LMS</a:t>
+              <a:t>Tanpa bobot atau nilai terpisah; pakai temuan untuk proyek</a:t>
             </a:r>
             <a:endParaRPr sz="1200"/>
           </a:p>
@@ -24707,7 +24751,7 @@
                 <a:ea typeface="Calibri"/>
                 <a:cs typeface="Calibri"/>
               </a:rPr>
-              <a:t>Bobot contoh</a:t>
+              <a:t>Fokus</a:t>
             </a:r>
             <a:endParaRPr sz="1100"/>
           </a:p>
@@ -24753,7 +24797,7 @@
                 <a:ea typeface="Calibri"/>
                 <a:cs typeface="Calibri"/>
               </a:rPr>
-              <a:t>Excellent (A)</a:t>
+              <a:t>Sudah kuat</a:t>
             </a:r>
             <a:endParaRPr sz="1100"/>
           </a:p>
@@ -24799,7 +24843,7 @@
                 <a:ea typeface="Calibri"/>
                 <a:cs typeface="Calibri"/>
               </a:rPr>
-              <a:t>Good (B)</a:t>
+              <a:t>Perlu ulas</a:t>
             </a:r>
             <a:endParaRPr sz="1100"/>
           </a:p>
@@ -24845,7 +24889,7 @@
                 <a:ea typeface="Calibri"/>
                 <a:cs typeface="Calibri"/>
               </a:rPr>
-              <a:t>Needs Work (C)</a:t>
+              <a:t>Coba ulang</a:t>
             </a:r>
             <a:endParaRPr sz="1100"/>
           </a:p>
@@ -25003,7 +25047,7 @@
                 <a:ea typeface="Consolas"/>
                 <a:cs typeface="Consolas"/>
               </a:rPr>
-              <a:t>30%</a:t>
+              <a:t>File</a:t>
             </a:r>
             <a:endParaRPr sz="1400"/>
           </a:p>
@@ -25299,7 +25343,7 @@
                 <a:ea typeface="Consolas"/>
                 <a:cs typeface="Consolas"/>
               </a:rPr>
-              <a:t>25%</a:t>
+              <a:t>Skrip</a:t>
             </a:r>
             <a:endParaRPr sz="1400"/>
           </a:p>
@@ -25595,7 +25639,7 @@
                 <a:ea typeface="Consolas"/>
                 <a:cs typeface="Consolas"/>
               </a:rPr>
-              <a:t>15%</a:t>
+              <a:t>Uji</a:t>
             </a:r>
             <a:endParaRPr sz="1400"/>
           </a:p>
@@ -25891,7 +25935,7 @@
                 <a:ea typeface="Consolas"/>
                 <a:cs typeface="Consolas"/>
               </a:rPr>
-              <a:t>20%</a:t>
+              <a:t>Catatan</a:t>
             </a:r>
             <a:endParaRPr sz="1400"/>
           </a:p>
@@ -26187,7 +26231,7 @@
                 <a:ea typeface="Consolas"/>
                 <a:cs typeface="Consolas"/>
               </a:rPr>
-              <a:t>10%</a:t>
+              <a:t>Konsep</a:t>
             </a:r>
             <a:endParaRPr sz="1400"/>
           </a:p>
@@ -26371,7 +26415,7 @@
                 <a:ea typeface="Calibri"/>
                 <a:cs typeface="Calibri"/>
               </a:rPr>
-              <a:t>Kumpulkan melalui repo pribadi dan kanal kelas yang ditetapkan dosen.</a:t>
+              <a:t>Dosen memberi umpan balik; penilaian lab berasal dari proyek kelompok.</a:t>
             </a:r>
             <a:endParaRPr sz="1100"/>
           </a:p>
@@ -26540,7 +26584,7 @@
           <p:nvPr/>
         </p:nvPicPr>
         <p:blipFill>
-          <a:blip xmlns:r="http://schemas.openxmlformats.org/officeDocument/2006/relationships" xmlns:a="http://schemas.openxmlformats.org/drawingml/2006/main" r:embed="Raa31a2adb4f04b7e"/>
+          <a:blip xmlns:r="http://schemas.openxmlformats.org/officeDocument/2006/relationships" xmlns:a="http://schemas.openxmlformats.org/drawingml/2006/main" r:embed="Ref87298c11b34e69"/>
           <a:stretch xmlns:a="http://schemas.openxmlformats.org/drawingml/2006/main">
             <a:fillRect l="0" t="0" r="0" b="0"/>
           </a:stretch>
@@ -26564,7 +26608,7 @@
           <p:nvPr/>
         </p:nvPicPr>
         <p:blipFill>
-          <a:blip xmlns:r="http://schemas.openxmlformats.org/officeDocument/2006/relationships" xmlns:a="http://schemas.openxmlformats.org/drawingml/2006/main" r:embed="R127f1b9f9c854291"/>
+          <a:blip xmlns:r="http://schemas.openxmlformats.org/officeDocument/2006/relationships" xmlns:a="http://schemas.openxmlformats.org/drawingml/2006/main" r:embed="Ra8b82c50cc094ece"/>
           <a:stretch xmlns:a="http://schemas.openxmlformats.org/drawingml/2006/main">
             <a:fillRect l="0" t="0" r="0" b="0"/>
           </a:stretch>
@@ -26696,7 +26740,7 @@
                 <a:ea typeface="Calibri"/>
                 <a:cs typeface="Calibri"/>
               </a:rPr>
-              <a:t>Yang sering bikin stuck atau nilai turun</a:t>
+              <a:t>Yang sering membuat skrip gagal; cara memperbaikinya</a:t>
             </a:r>
             <a:endParaRPr sz="1200"/>
           </a:p>
@@ -28353,7 +28397,7 @@
           <p:nvPr/>
         </p:nvPicPr>
         <p:blipFill>
-          <a:blip xmlns:r="http://schemas.openxmlformats.org/officeDocument/2006/relationships" xmlns:a="http://schemas.openxmlformats.org/drawingml/2006/main" r:embed="Rc3bd1a916d884e07"/>
+          <a:blip xmlns:r="http://schemas.openxmlformats.org/officeDocument/2006/relationships" xmlns:a="http://schemas.openxmlformats.org/drawingml/2006/main" r:embed="Rc54ce3f497e540cb"/>
           <a:stretch xmlns:a="http://schemas.openxmlformats.org/drawingml/2006/main">
             <a:fillRect l="0" t="0" r="0" b="0"/>
           </a:stretch>
@@ -28377,7 +28421,7 @@
           <p:nvPr/>
         </p:nvPicPr>
         <p:blipFill>
-          <a:blip xmlns:r="http://schemas.openxmlformats.org/officeDocument/2006/relationships" xmlns:a="http://schemas.openxmlformats.org/drawingml/2006/main" r:embed="Rf2800f4263b142de"/>
+          <a:blip xmlns:r="http://schemas.openxmlformats.org/officeDocument/2006/relationships" xmlns:a="http://schemas.openxmlformats.org/drawingml/2006/main" r:embed="Red258afac9a54137"/>
           <a:stretch xmlns:a="http://schemas.openxmlformats.org/drawingml/2006/main">
             <a:fillRect l="0" t="0" r="0" b="0"/>
           </a:stretch>
@@ -30766,7 +30810,7 @@
           <p:nvPr/>
         </p:nvPicPr>
         <p:blipFill>
-          <a:blip xmlns:r="http://schemas.openxmlformats.org/officeDocument/2006/relationships" xmlns:a="http://schemas.openxmlformats.org/drawingml/2006/main" r:embed="R0de85c4a06594c3b"/>
+          <a:blip xmlns:r="http://schemas.openxmlformats.org/officeDocument/2006/relationships" xmlns:a="http://schemas.openxmlformats.org/drawingml/2006/main" r:embed="R8e0a19b631914719"/>
           <a:stretch xmlns:a="http://schemas.openxmlformats.org/drawingml/2006/main">
             <a:fillRect l="0" t="0" r="0" b="0"/>
           </a:stretch>
@@ -30790,7 +30834,7 @@
           <p:nvPr/>
         </p:nvPicPr>
         <p:blipFill>
-          <a:blip xmlns:r="http://schemas.openxmlformats.org/officeDocument/2006/relationships" xmlns:a="http://schemas.openxmlformats.org/drawingml/2006/main" r:embed="R0754aee94b174a5f"/>
+          <a:blip xmlns:r="http://schemas.openxmlformats.org/officeDocument/2006/relationships" xmlns:a="http://schemas.openxmlformats.org/drawingml/2006/main" r:embed="R982da7c7d5f5481d"/>
           <a:stretch xmlns:a="http://schemas.openxmlformats.org/drawingml/2006/main">
             <a:fillRect l="0" t="0" r="0" b="0"/>
           </a:stretch>
@@ -32563,7 +32607,7 @@
           <p:nvPr/>
         </p:nvPicPr>
         <p:blipFill>
-          <a:blip xmlns:r="http://schemas.openxmlformats.org/officeDocument/2006/relationships" xmlns:a="http://schemas.openxmlformats.org/drawingml/2006/main" r:embed="R78fae482180343a1"/>
+          <a:blip xmlns:r="http://schemas.openxmlformats.org/officeDocument/2006/relationships" xmlns:a="http://schemas.openxmlformats.org/drawingml/2006/main" r:embed="Rd9c95b8b7c1640f1"/>
           <a:stretch xmlns:a="http://schemas.openxmlformats.org/drawingml/2006/main">
             <a:fillRect l="0" t="0" r="0" b="0"/>
           </a:stretch>
@@ -32587,7 +32631,7 @@
           <p:nvPr/>
         </p:nvPicPr>
         <p:blipFill>
-          <a:blip xmlns:r="http://schemas.openxmlformats.org/officeDocument/2006/relationships" xmlns:a="http://schemas.openxmlformats.org/drawingml/2006/main" r:embed="R0d4c3bf407104450"/>
+          <a:blip xmlns:r="http://schemas.openxmlformats.org/officeDocument/2006/relationships" xmlns:a="http://schemas.openxmlformats.org/drawingml/2006/main" r:embed="R789551a7ff264659"/>
           <a:stretch xmlns:a="http://schemas.openxmlformats.org/drawingml/2006/main">
             <a:fillRect l="0" t="0" r="0" b="0"/>
           </a:stretch>
@@ -32719,7 +32763,7 @@
                 <a:ea typeface="Calibri"/>
                 <a:cs typeface="Calibri"/>
               </a:rPr>
-              <a:t>Lihat panduan dosen untuk checkpoint dan kunci lengkap</a:t>
+              <a:t>Ikuti modul mahasiswa untuk checkpoint dan contoh hasil</a:t>
             </a:r>
             <a:endParaRPr sz="1200"/>
           </a:p>
@@ -32879,7 +32923,7 @@
           <p:nvPr/>
         </p:nvPicPr>
         <p:blipFill>
-          <a:blip xmlns:r="http://schemas.openxmlformats.org/officeDocument/2006/relationships" xmlns:a="http://schemas.openxmlformats.org/drawingml/2006/main" r:embed="R80d2845d54ed4290"/>
+          <a:blip xmlns:r="http://schemas.openxmlformats.org/officeDocument/2006/relationships" xmlns:a="http://schemas.openxmlformats.org/drawingml/2006/main" r:embed="Rc6a37e6a672949a1"/>
           <a:stretch xmlns:a="http://schemas.openxmlformats.org/drawingml/2006/main">
             <a:fillRect l="0" t="0" r="0" b="0"/>
           </a:stretch>
@@ -33140,7 +33184,7 @@
           <p:nvPr/>
         </p:nvPicPr>
         <p:blipFill>
-          <a:blip xmlns:r="http://schemas.openxmlformats.org/officeDocument/2006/relationships" xmlns:a="http://schemas.openxmlformats.org/drawingml/2006/main" r:embed="Rba653208860f4c41"/>
+          <a:blip xmlns:r="http://schemas.openxmlformats.org/officeDocument/2006/relationships" xmlns:a="http://schemas.openxmlformats.org/drawingml/2006/main" r:embed="R7db9421647014a65"/>
           <a:stretch xmlns:a="http://schemas.openxmlformats.org/drawingml/2006/main">
             <a:fillRect l="0" t="0" r="0" b="0"/>
           </a:stretch>
@@ -33401,7 +33445,7 @@
           <p:nvPr/>
         </p:nvPicPr>
         <p:blipFill>
-          <a:blip xmlns:r="http://schemas.openxmlformats.org/officeDocument/2006/relationships" xmlns:a="http://schemas.openxmlformats.org/drawingml/2006/main" r:embed="R88376ff54be34924"/>
+          <a:blip xmlns:r="http://schemas.openxmlformats.org/officeDocument/2006/relationships" xmlns:a="http://schemas.openxmlformats.org/drawingml/2006/main" r:embed="R6f224f74e9f9409b"/>
           <a:stretch xmlns:a="http://schemas.openxmlformats.org/drawingml/2006/main">
             <a:fillRect l="0" t="0" r="0" b="0"/>
           </a:stretch>
@@ -33662,7 +33706,7 @@
           <p:nvPr/>
         </p:nvPicPr>
         <p:blipFill>
-          <a:blip xmlns:r="http://schemas.openxmlformats.org/officeDocument/2006/relationships" xmlns:a="http://schemas.openxmlformats.org/drawingml/2006/main" r:embed="Radc01eaad8424006"/>
+          <a:blip xmlns:r="http://schemas.openxmlformats.org/officeDocument/2006/relationships" xmlns:a="http://schemas.openxmlformats.org/drawingml/2006/main" r:embed="Rd431dec9226a4bcb"/>
           <a:stretch xmlns:a="http://schemas.openxmlformats.org/drawingml/2006/main">
             <a:fillRect l="0" t="0" r="0" b="0"/>
           </a:stretch>
@@ -33923,7 +33967,7 @@
           <p:nvPr/>
         </p:nvPicPr>
         <p:blipFill>
-          <a:blip xmlns:r="http://schemas.openxmlformats.org/officeDocument/2006/relationships" xmlns:a="http://schemas.openxmlformats.org/drawingml/2006/main" r:embed="R0fb8a4e4dd574cba"/>
+          <a:blip xmlns:r="http://schemas.openxmlformats.org/officeDocument/2006/relationships" xmlns:a="http://schemas.openxmlformats.org/drawingml/2006/main" r:embed="R4d1670af24204475"/>
           <a:stretch xmlns:a="http://schemas.openxmlformats.org/drawingml/2006/main">
             <a:fillRect l="0" t="0" r="0" b="0"/>
           </a:stretch>
@@ -34184,7 +34228,7 @@
           <p:nvPr/>
         </p:nvPicPr>
         <p:blipFill>
-          <a:blip xmlns:r="http://schemas.openxmlformats.org/officeDocument/2006/relationships" xmlns:a="http://schemas.openxmlformats.org/drawingml/2006/main" r:embed="R7a3d04a589b84c4a"/>
+          <a:blip xmlns:r="http://schemas.openxmlformats.org/officeDocument/2006/relationships" xmlns:a="http://schemas.openxmlformats.org/drawingml/2006/main" r:embed="Rf1ee8539134143cd"/>
           <a:stretch xmlns:a="http://schemas.openxmlformats.org/drawingml/2006/main">
             <a:fillRect l="0" t="0" r="0" b="0"/>
           </a:stretch>
@@ -34285,7 +34329,7 @@
                 <a:ea typeface="Calibri"/>
                 <a:cs typeface="Calibri"/>
               </a:rPr>
-              <a:t>bash scripts/verify.sh -&gt; 0 gagal; isi laporan dan push.</a:t>
+              <a:t>bash scripts/verify.sh -&gt; 0 gagal; catat hasil; push bila berguna.</a:t>
             </a:r>
             <a:endParaRPr sz="950"/>
           </a:p>
@@ -34500,7 +34544,7 @@
           <p:nvPr/>
         </p:nvPicPr>
         <p:blipFill>
-          <a:blip xmlns:r="http://schemas.openxmlformats.org/officeDocument/2006/relationships" xmlns:a="http://schemas.openxmlformats.org/drawingml/2006/main" r:embed="R4167292828e6429d"/>
+          <a:blip xmlns:r="http://schemas.openxmlformats.org/officeDocument/2006/relationships" xmlns:a="http://schemas.openxmlformats.org/drawingml/2006/main" r:embed="Ra0071358e99c4933"/>
           <a:stretch xmlns:a="http://schemas.openxmlformats.org/drawingml/2006/main">
             <a:fillRect l="0" t="0" r="0" b="0"/>
           </a:stretch>
@@ -34524,7 +34568,7 @@
           <p:nvPr/>
         </p:nvPicPr>
         <p:blipFill>
-          <a:blip xmlns:r="http://schemas.openxmlformats.org/officeDocument/2006/relationships" xmlns:a="http://schemas.openxmlformats.org/drawingml/2006/main" r:embed="R12f2dfb959044b99"/>
+          <a:blip xmlns:r="http://schemas.openxmlformats.org/officeDocument/2006/relationships" xmlns:a="http://schemas.openxmlformats.org/drawingml/2006/main" r:embed="R2203741089ad42dc"/>
           <a:stretch xmlns:a="http://schemas.openxmlformats.org/drawingml/2006/main">
             <a:fillRect l="0" t="0" r="0" b="0"/>
           </a:stretch>
@@ -34750,7 +34794,7 @@
           <p:nvPr/>
         </p:nvPicPr>
         <p:blipFill>
-          <a:blip xmlns:r="http://schemas.openxmlformats.org/officeDocument/2006/relationships" xmlns:a="http://schemas.openxmlformats.org/drawingml/2006/main" r:embed="Rf8fade4575404d93"/>
+          <a:blip xmlns:r="http://schemas.openxmlformats.org/officeDocument/2006/relationships" xmlns:a="http://schemas.openxmlformats.org/drawingml/2006/main" r:embed="R56e205e43c5b4127"/>
           <a:stretch xmlns:a="http://schemas.openxmlformats.org/drawingml/2006/main">
             <a:fillRect l="0" t="0" r="0" b="0"/>
           </a:stretch>
@@ -34853,7 +34897,7 @@
           <p:nvPr/>
         </p:nvPicPr>
         <p:blipFill>
-          <a:blip xmlns:r="http://schemas.openxmlformats.org/officeDocument/2006/relationships" xmlns:a="http://schemas.openxmlformats.org/drawingml/2006/main" r:embed="Rf8fade4575404d93"/>
+          <a:blip xmlns:r="http://schemas.openxmlformats.org/officeDocument/2006/relationships" xmlns:a="http://schemas.openxmlformats.org/drawingml/2006/main" r:embed="R56e205e43c5b4127"/>
           <a:stretch xmlns:a="http://schemas.openxmlformats.org/drawingml/2006/main">
             <a:fillRect l="0" t="0" r="0" b="0"/>
           </a:stretch>
@@ -34956,7 +35000,7 @@
           <p:nvPr/>
         </p:nvPicPr>
         <p:blipFill>
-          <a:blip xmlns:r="http://schemas.openxmlformats.org/officeDocument/2006/relationships" xmlns:a="http://schemas.openxmlformats.org/drawingml/2006/main" r:embed="Rf8fade4575404d93"/>
+          <a:blip xmlns:r="http://schemas.openxmlformats.org/officeDocument/2006/relationships" xmlns:a="http://schemas.openxmlformats.org/drawingml/2006/main" r:embed="R56e205e43c5b4127"/>
           <a:stretch xmlns:a="http://schemas.openxmlformats.org/drawingml/2006/main">
             <a:fillRect l="0" t="0" r="0" b="0"/>
           </a:stretch>
@@ -35059,7 +35103,7 @@
           <p:nvPr/>
         </p:nvPicPr>
         <p:blipFill>
-          <a:blip xmlns:r="http://schemas.openxmlformats.org/officeDocument/2006/relationships" xmlns:a="http://schemas.openxmlformats.org/drawingml/2006/main" r:embed="Rf8fade4575404d93"/>
+          <a:blip xmlns:r="http://schemas.openxmlformats.org/officeDocument/2006/relationships" xmlns:a="http://schemas.openxmlformats.org/drawingml/2006/main" r:embed="R56e205e43c5b4127"/>
           <a:stretch xmlns:a="http://schemas.openxmlformats.org/drawingml/2006/main">
             <a:fillRect l="0" t="0" r="0" b="0"/>
           </a:stretch>
@@ -35162,7 +35206,7 @@
           <p:nvPr/>
         </p:nvPicPr>
         <p:blipFill>
-          <a:blip xmlns:r="http://schemas.openxmlformats.org/officeDocument/2006/relationships" xmlns:a="http://schemas.openxmlformats.org/drawingml/2006/main" r:embed="Rf8fade4575404d93"/>
+          <a:blip xmlns:r="http://schemas.openxmlformats.org/officeDocument/2006/relationships" xmlns:a="http://schemas.openxmlformats.org/drawingml/2006/main" r:embed="R56e205e43c5b4127"/>
           <a:stretch xmlns:a="http://schemas.openxmlformats.org/drawingml/2006/main">
             <a:fillRect l="0" t="0" r="0" b="0"/>
           </a:stretch>
@@ -35265,7 +35309,7 @@
           <p:nvPr/>
         </p:nvPicPr>
         <p:blipFill>
-          <a:blip xmlns:r="http://schemas.openxmlformats.org/officeDocument/2006/relationships" xmlns:a="http://schemas.openxmlformats.org/drawingml/2006/main" r:embed="Rf8fade4575404d93"/>
+          <a:blip xmlns:r="http://schemas.openxmlformats.org/officeDocument/2006/relationships" xmlns:a="http://schemas.openxmlformats.org/drawingml/2006/main" r:embed="R56e205e43c5b4127"/>
           <a:stretch xmlns:a="http://schemas.openxmlformats.org/drawingml/2006/main">
             <a:fillRect l="0" t="0" r="0" b="0"/>
           </a:stretch>
@@ -35368,7 +35412,7 @@
           <p:nvPr/>
         </p:nvPicPr>
         <p:blipFill>
-          <a:blip xmlns:r="http://schemas.openxmlformats.org/officeDocument/2006/relationships" xmlns:a="http://schemas.openxmlformats.org/drawingml/2006/main" r:embed="Rf8fade4575404d93"/>
+          <a:blip xmlns:r="http://schemas.openxmlformats.org/officeDocument/2006/relationships" xmlns:a="http://schemas.openxmlformats.org/drawingml/2006/main" r:embed="R56e205e43c5b4127"/>
           <a:stretch xmlns:a="http://schemas.openxmlformats.org/drawingml/2006/main">
             <a:fillRect l="0" t="0" r="0" b="0"/>
           </a:stretch>
@@ -35471,7 +35515,7 @@
           <p:nvPr/>
         </p:nvPicPr>
         <p:blipFill>
-          <a:blip xmlns:r="http://schemas.openxmlformats.org/officeDocument/2006/relationships" xmlns:a="http://schemas.openxmlformats.org/drawingml/2006/main" r:embed="R9cc6f03e303d4534"/>
+          <a:blip xmlns:r="http://schemas.openxmlformats.org/officeDocument/2006/relationships" xmlns:a="http://schemas.openxmlformats.org/drawingml/2006/main" r:embed="R11109bc61b9a4774"/>
           <a:stretch xmlns:a="http://schemas.openxmlformats.org/drawingml/2006/main">
             <a:fillRect l="0" t="0" r="0" b="0"/>
           </a:stretch>
@@ -35526,7 +35570,7 @@
                 <a:ea typeface="Calibri"/>
                 <a:cs typeface="Calibri"/>
               </a:rPr>
-              <a:t>SUBMIT BEFORE PRAKTIKUM 3</a:t>
+              <a:t>APLIKASIKAN KE PROYEK</a:t>
             </a:r>
             <a:endParaRPr sz="1100"/>
           </a:p>
@@ -35572,7 +35616,7 @@
                 <a:ea typeface="Calibri"/>
                 <a:cs typeface="Calibri"/>
               </a:rPr>
-              <a:t>Deadline submission</a:t>
+              <a:t>Kelompok 3 orang</a:t>
             </a:r>
             <a:endParaRPr sz="1400"/>
           </a:p>
@@ -35621,10 +35665,43 @@
                 <a:ea typeface="Calibri"/>
                 <a:cs typeface="Calibri"/>
               </a:rPr>
-              <a:t>[ ] Lima artefak workspace/
-[ ] check-status.sh dan Hasil: 0 gagal
-[ ] hasil/lab02.md dan screenshot pribadi
-[ ] Commit/push repo sendiri</a:t>
+              <a:t>[ ] Pakai Bash untuk setup proyek</a:t>
+            </a:r>
+            <a:br/>
+            <a:r>
+              <a:rPr sz="1100">
+                <a:solidFill>
+                  <a:srgbClr val="FFFFFF"/>
+                </a:solidFill>
+                <a:latin typeface="Calibri"/>
+                <a:ea typeface="Calibri"/>
+                <a:cs typeface="Calibri"/>
+              </a:rPr>
+              <a:t>[ ] Atur izin file dan secret</a:t>
+            </a:r>
+            <a:br/>
+            <a:r>
+              <a:rPr sz="1100">
+                <a:solidFill>
+                  <a:srgbClr val="FFFFFF"/>
+                </a:solidFill>
+                <a:latin typeface="Calibri"/>
+                <a:ea typeface="Calibri"/>
+                <a:cs typeface="Calibri"/>
+              </a:rPr>
+              <a:t>[ ] Simpan catatan bila membantu</a:t>
+            </a:r>
+            <a:br/>
+            <a:r>
+              <a:rPr sz="1100">
+                <a:solidFill>
+                  <a:srgbClr val="FFFFFF"/>
+                </a:solidFill>
+                <a:latin typeface="Calibri"/>
+                <a:ea typeface="Calibri"/>
+                <a:cs typeface="Calibri"/>
+              </a:rPr>
+              <a:t>[ ] Presentasi minggu 7 dan 14</a:t>
             </a:r>
             <a:endParaRPr sz="1100"/>
           </a:p>
@@ -35672,7 +35749,7 @@
           <p:nvPr/>
         </p:nvPicPr>
         <p:blipFill>
-          <a:blip xmlns:r="http://schemas.openxmlformats.org/officeDocument/2006/relationships" xmlns:a="http://schemas.openxmlformats.org/drawingml/2006/main" r:embed="Re75dbedba30d4599"/>
+          <a:blip xmlns:r="http://schemas.openxmlformats.org/officeDocument/2006/relationships" xmlns:a="http://schemas.openxmlformats.org/drawingml/2006/main" r:embed="Rb14e7d7784354b2c"/>
           <a:stretch xmlns:a="http://schemas.openxmlformats.org/drawingml/2006/main">
             <a:fillRect l="0" t="0" r="0" b="0"/>
           </a:stretch>
@@ -35867,7 +35944,7 @@
           <p:nvPr/>
         </p:nvPicPr>
         <p:blipFill>
-          <a:blip xmlns:r="http://schemas.openxmlformats.org/officeDocument/2006/relationships" xmlns:a="http://schemas.openxmlformats.org/drawingml/2006/main" r:embed="R5d46638f545f4b1e"/>
+          <a:blip xmlns:r="http://schemas.openxmlformats.org/officeDocument/2006/relationships" xmlns:a="http://schemas.openxmlformats.org/drawingml/2006/main" r:embed="R63623ea221624894"/>
           <a:stretch xmlns:a="http://schemas.openxmlformats.org/drawingml/2006/main">
             <a:fillRect l="0" t="0" r="0" b="0"/>
           </a:stretch>
@@ -35968,7 +36045,7 @@
                 <a:ea typeface="Calibri"/>
                 <a:cs typeface="Calibri"/>
               </a:rPr>
-              <a:t>Tanya dosen atau lihat PANDUAN_DOSEN.md di repo.</a:t>
+              <a:t>Tanya dosen saat kelas; panduan mahasiswa tersedia di repo.</a:t>
             </a:r>
             <a:endParaRPr sz="1200"/>
           </a:p>
@@ -36137,7 +36214,7 @@
           <p:nvPr/>
         </p:nvPicPr>
         <p:blipFill>
-          <a:blip xmlns:r="http://schemas.openxmlformats.org/officeDocument/2006/relationships" xmlns:a="http://schemas.openxmlformats.org/drawingml/2006/main" r:embed="R0d2b2dae17474ae1"/>
+          <a:blip xmlns:r="http://schemas.openxmlformats.org/officeDocument/2006/relationships" xmlns:a="http://schemas.openxmlformats.org/drawingml/2006/main" r:embed="Rcdff436d03db4632"/>
           <a:stretch xmlns:a="http://schemas.openxmlformats.org/drawingml/2006/main">
             <a:fillRect l="0" t="0" r="0" b="0"/>
           </a:stretch>
@@ -36161,7 +36238,7 @@
           <p:nvPr/>
         </p:nvPicPr>
         <p:blipFill>
-          <a:blip xmlns:r="http://schemas.openxmlformats.org/officeDocument/2006/relationships" xmlns:a="http://schemas.openxmlformats.org/drawingml/2006/main" r:embed="R24bc91dad0ee43f2"/>
+          <a:blip xmlns:r="http://schemas.openxmlformats.org/officeDocument/2006/relationships" xmlns:a="http://schemas.openxmlformats.org/drawingml/2006/main" r:embed="Rf30bd8d89d69431e"/>
           <a:stretch xmlns:a="http://schemas.openxmlformats.org/drawingml/2006/main">
             <a:fillRect l="0" t="0" r="0" b="0"/>
           </a:stretch>
@@ -36399,7 +36476,7 @@
           <p:nvPr/>
         </p:nvPicPr>
         <p:blipFill>
-          <a:blip xmlns:r="http://schemas.openxmlformats.org/officeDocument/2006/relationships" xmlns:a="http://schemas.openxmlformats.org/drawingml/2006/main" r:embed="Rf6db695994e74d19"/>
+          <a:blip xmlns:r="http://schemas.openxmlformats.org/officeDocument/2006/relationships" xmlns:a="http://schemas.openxmlformats.org/drawingml/2006/main" r:embed="R7dbdea0813994833"/>
           <a:stretch xmlns:a="http://schemas.openxmlformats.org/drawingml/2006/main">
             <a:fillRect l="0" t="0" r="0" b="0"/>
           </a:stretch>
@@ -36469,7 +36546,7 @@
           <p:nvPr/>
         </p:nvPicPr>
         <p:blipFill>
-          <a:blip xmlns:r="http://schemas.openxmlformats.org/officeDocument/2006/relationships" xmlns:a="http://schemas.openxmlformats.org/drawingml/2006/main" r:embed="Rf1c76cba9c6d4b06"/>
+          <a:blip xmlns:r="http://schemas.openxmlformats.org/officeDocument/2006/relationships" xmlns:a="http://schemas.openxmlformats.org/drawingml/2006/main" r:embed="R52c08df71aa449fc"/>
           <a:stretch xmlns:a="http://schemas.openxmlformats.org/drawingml/2006/main">
             <a:fillRect l="0" t="0" r="0" b="0"/>
           </a:stretch>
@@ -36539,7 +36616,7 @@
           <p:nvPr/>
         </p:nvPicPr>
         <p:blipFill>
-          <a:blip xmlns:r="http://schemas.openxmlformats.org/officeDocument/2006/relationships" xmlns:a="http://schemas.openxmlformats.org/drawingml/2006/main" r:embed="R43aa181af5614ac4"/>
+          <a:blip xmlns:r="http://schemas.openxmlformats.org/officeDocument/2006/relationships" xmlns:a="http://schemas.openxmlformats.org/drawingml/2006/main" r:embed="R3411ed3ca4b1444b"/>
           <a:stretch xmlns:a="http://schemas.openxmlformats.org/drawingml/2006/main">
             <a:fillRect l="0" t="0" r="0" b="0"/>
           </a:stretch>
@@ -36609,7 +36686,7 @@
           <p:nvPr/>
         </p:nvPicPr>
         <p:blipFill>
-          <a:blip xmlns:r="http://schemas.openxmlformats.org/officeDocument/2006/relationships" xmlns:a="http://schemas.openxmlformats.org/drawingml/2006/main" r:embed="Rdb4b6b7068e64916"/>
+          <a:blip xmlns:r="http://schemas.openxmlformats.org/officeDocument/2006/relationships" xmlns:a="http://schemas.openxmlformats.org/drawingml/2006/main" r:embed="Raa3947fbd2494e3c"/>
           <a:stretch xmlns:a="http://schemas.openxmlformats.org/drawingml/2006/main">
             <a:fillRect l="0" t="0" r="0" b="0"/>
           </a:stretch>
@@ -36679,7 +36756,7 @@
           <p:nvPr/>
         </p:nvPicPr>
         <p:blipFill>
-          <a:blip xmlns:r="http://schemas.openxmlformats.org/officeDocument/2006/relationships" xmlns:a="http://schemas.openxmlformats.org/drawingml/2006/main" r:embed="Re81468da9b3c4df3"/>
+          <a:blip xmlns:r="http://schemas.openxmlformats.org/officeDocument/2006/relationships" xmlns:a="http://schemas.openxmlformats.org/drawingml/2006/main" r:embed="Rc3d03e686fff495f"/>
           <a:stretch xmlns:a="http://schemas.openxmlformats.org/drawingml/2006/main">
             <a:fillRect l="0" t="0" r="0" b="0"/>
           </a:stretch>
@@ -36749,7 +36826,7 @@
           <p:nvPr/>
         </p:nvPicPr>
         <p:blipFill>
-          <a:blip xmlns:r="http://schemas.openxmlformats.org/officeDocument/2006/relationships" xmlns:a="http://schemas.openxmlformats.org/drawingml/2006/main" r:embed="R120d6035c0a34e0c"/>
+          <a:blip xmlns:r="http://schemas.openxmlformats.org/officeDocument/2006/relationships" xmlns:a="http://schemas.openxmlformats.org/drawingml/2006/main" r:embed="R481ca913b8f34ac1"/>
           <a:stretch xmlns:a="http://schemas.openxmlformats.org/drawingml/2006/main">
             <a:fillRect l="0" t="0" r="0" b="0"/>
           </a:stretch>
@@ -37192,7 +37269,7 @@
           <p:nvPr/>
         </p:nvPicPr>
         <p:blipFill>
-          <a:blip xmlns:r="http://schemas.openxmlformats.org/officeDocument/2006/relationships" xmlns:a="http://schemas.openxmlformats.org/drawingml/2006/main" r:embed="Re043aa89ea0e4131"/>
+          <a:blip xmlns:r="http://schemas.openxmlformats.org/officeDocument/2006/relationships" xmlns:a="http://schemas.openxmlformats.org/drawingml/2006/main" r:embed="R1e763740c6454d7c"/>
           <a:stretch xmlns:a="http://schemas.openxmlformats.org/drawingml/2006/main">
             <a:fillRect l="0" t="0" r="0" b="0"/>
           </a:stretch>
@@ -37216,7 +37293,7 @@
           <p:nvPr/>
         </p:nvPicPr>
         <p:blipFill>
-          <a:blip xmlns:r="http://schemas.openxmlformats.org/officeDocument/2006/relationships" xmlns:a="http://schemas.openxmlformats.org/drawingml/2006/main" r:embed="Rf3a54fb062894083"/>
+          <a:blip xmlns:r="http://schemas.openxmlformats.org/officeDocument/2006/relationships" xmlns:a="http://schemas.openxmlformats.org/drawingml/2006/main" r:embed="R85e93429b89d4a37"/>
           <a:stretch xmlns:a="http://schemas.openxmlformats.org/drawingml/2006/main">
             <a:fillRect l="0" t="0" r="0" b="0"/>
           </a:stretch>
@@ -37421,7 +37498,7 @@
           <p:nvPr/>
         </p:nvPicPr>
         <p:blipFill>
-          <a:blip xmlns:r="http://schemas.openxmlformats.org/officeDocument/2006/relationships" xmlns:a="http://schemas.openxmlformats.org/drawingml/2006/main" r:embed="Rcb968436c7294599"/>
+          <a:blip xmlns:r="http://schemas.openxmlformats.org/officeDocument/2006/relationships" xmlns:a="http://schemas.openxmlformats.org/drawingml/2006/main" r:embed="R32481682af144db2"/>
           <a:stretch xmlns:a="http://schemas.openxmlformats.org/drawingml/2006/main">
             <a:fillRect l="0" t="0" r="0" b="0"/>
           </a:stretch>
@@ -37979,7 +38056,7 @@
           <p:nvPr/>
         </p:nvPicPr>
         <p:blipFill>
-          <a:blip xmlns:r="http://schemas.openxmlformats.org/officeDocument/2006/relationships" xmlns:a="http://schemas.openxmlformats.org/drawingml/2006/main" r:embed="Rfeeccfd7e4fe493a"/>
+          <a:blip xmlns:r="http://schemas.openxmlformats.org/officeDocument/2006/relationships" xmlns:a="http://schemas.openxmlformats.org/drawingml/2006/main" r:embed="R512e6dda7df24eee"/>
           <a:stretch xmlns:a="http://schemas.openxmlformats.org/drawingml/2006/main">
             <a:fillRect l="0" t="0" r="0" b="0"/>
           </a:stretch>
@@ -38003,7 +38080,7 @@
           <p:nvPr/>
         </p:nvPicPr>
         <p:blipFill>
-          <a:blip xmlns:r="http://schemas.openxmlformats.org/officeDocument/2006/relationships" xmlns:a="http://schemas.openxmlformats.org/drawingml/2006/main" r:embed="R6bfce0abf8af4588"/>
+          <a:blip xmlns:r="http://schemas.openxmlformats.org/officeDocument/2006/relationships" xmlns:a="http://schemas.openxmlformats.org/drawingml/2006/main" r:embed="R3e0a15ab224e476a"/>
           <a:stretch xmlns:a="http://schemas.openxmlformats.org/drawingml/2006/main">
             <a:fillRect l="0" t="0" r="0" b="0"/>
           </a:stretch>
@@ -38208,7 +38285,7 @@
           <p:nvPr/>
         </p:nvPicPr>
         <p:blipFill>
-          <a:blip xmlns:r="http://schemas.openxmlformats.org/officeDocument/2006/relationships" xmlns:a="http://schemas.openxmlformats.org/drawingml/2006/main" r:embed="R40f4f27eb7ee4cae"/>
+          <a:blip xmlns:r="http://schemas.openxmlformats.org/officeDocument/2006/relationships" xmlns:a="http://schemas.openxmlformats.org/drawingml/2006/main" r:embed="Rcfb831e2939f4ca7"/>
           <a:stretch xmlns:a="http://schemas.openxmlformats.org/drawingml/2006/main">
             <a:fillRect l="0" t="0" r="0" b="0"/>
           </a:stretch>
@@ -38767,7 +38844,7 @@
           <p:nvPr/>
         </p:nvPicPr>
         <p:blipFill>
-          <a:blip xmlns:r="http://schemas.openxmlformats.org/officeDocument/2006/relationships" xmlns:a="http://schemas.openxmlformats.org/drawingml/2006/main" r:embed="R680c18b162334664"/>
+          <a:blip xmlns:r="http://schemas.openxmlformats.org/officeDocument/2006/relationships" xmlns:a="http://schemas.openxmlformats.org/drawingml/2006/main" r:embed="Re57ca603f6bf410e"/>
           <a:stretch xmlns:a="http://schemas.openxmlformats.org/drawingml/2006/main">
             <a:fillRect l="0" t="0" r="0" b="0"/>
           </a:stretch>
@@ -38791,7 +38868,7 @@
           <p:nvPr/>
         </p:nvPicPr>
         <p:blipFill>
-          <a:blip xmlns:r="http://schemas.openxmlformats.org/officeDocument/2006/relationships" xmlns:a="http://schemas.openxmlformats.org/drawingml/2006/main" r:embed="Reacb49febb9b48b4"/>
+          <a:blip xmlns:r="http://schemas.openxmlformats.org/officeDocument/2006/relationships" xmlns:a="http://schemas.openxmlformats.org/drawingml/2006/main" r:embed="R666bc1c3b8a24c20"/>
           <a:stretch xmlns:a="http://schemas.openxmlformats.org/drawingml/2006/main">
             <a:fillRect l="0" t="0" r="0" b="0"/>
           </a:stretch>
@@ -38996,7 +39073,7 @@
           <p:nvPr/>
         </p:nvPicPr>
         <p:blipFill>
-          <a:blip xmlns:r="http://schemas.openxmlformats.org/officeDocument/2006/relationships" xmlns:a="http://schemas.openxmlformats.org/drawingml/2006/main" r:embed="R7171c8e2232a419d"/>
+          <a:blip xmlns:r="http://schemas.openxmlformats.org/officeDocument/2006/relationships" xmlns:a="http://schemas.openxmlformats.org/drawingml/2006/main" r:embed="R8ea1fb69d5844608"/>
           <a:stretch xmlns:a="http://schemas.openxmlformats.org/drawingml/2006/main">
             <a:fillRect l="0" t="0" r="0" b="0"/>
           </a:stretch>
@@ -39553,7 +39630,7 @@
           <p:nvPr/>
         </p:nvPicPr>
         <p:blipFill>
-          <a:blip xmlns:r="http://schemas.openxmlformats.org/officeDocument/2006/relationships" xmlns:a="http://schemas.openxmlformats.org/drawingml/2006/main" r:embed="Rec34cc9dbf88460b"/>
+          <a:blip xmlns:r="http://schemas.openxmlformats.org/officeDocument/2006/relationships" xmlns:a="http://schemas.openxmlformats.org/drawingml/2006/main" r:embed="Rb02f1e20dfe74868"/>
           <a:stretch xmlns:a="http://schemas.openxmlformats.org/drawingml/2006/main">
             <a:fillRect l="0" t="0" r="0" b="0"/>
           </a:stretch>
@@ -39577,7 +39654,7 @@
           <p:nvPr/>
         </p:nvPicPr>
         <p:blipFill>
-          <a:blip xmlns:r="http://schemas.openxmlformats.org/officeDocument/2006/relationships" xmlns:a="http://schemas.openxmlformats.org/drawingml/2006/main" r:embed="R10c31b17a5c8492e"/>
+          <a:blip xmlns:r="http://schemas.openxmlformats.org/officeDocument/2006/relationships" xmlns:a="http://schemas.openxmlformats.org/drawingml/2006/main" r:embed="R0d96e0d8ae8c4010"/>
           <a:stretch xmlns:a="http://schemas.openxmlformats.org/drawingml/2006/main">
             <a:fillRect l="0" t="0" r="0" b="0"/>
           </a:stretch>
@@ -39782,7 +39859,7 @@
           <p:nvPr/>
         </p:nvPicPr>
         <p:blipFill>
-          <a:blip xmlns:r="http://schemas.openxmlformats.org/officeDocument/2006/relationships" xmlns:a="http://schemas.openxmlformats.org/drawingml/2006/main" r:embed="Race3775af40845bc"/>
+          <a:blip xmlns:r="http://schemas.openxmlformats.org/officeDocument/2006/relationships" xmlns:a="http://schemas.openxmlformats.org/drawingml/2006/main" r:embed="Re0f17ce5fe274304"/>
           <a:stretch xmlns:a="http://schemas.openxmlformats.org/drawingml/2006/main">
             <a:fillRect l="0" t="0" r="0" b="0"/>
           </a:stretch>
@@ -40335,7 +40412,7 @@
           <p:nvPr/>
         </p:nvPicPr>
         <p:blipFill>
-          <a:blip xmlns:r="http://schemas.openxmlformats.org/officeDocument/2006/relationships" xmlns:a="http://schemas.openxmlformats.org/drawingml/2006/main" r:embed="R70c87e906d5c40f5"/>
+          <a:blip xmlns:r="http://schemas.openxmlformats.org/officeDocument/2006/relationships" xmlns:a="http://schemas.openxmlformats.org/drawingml/2006/main" r:embed="R250d4c8911a340bc"/>
           <a:stretch xmlns:a="http://schemas.openxmlformats.org/drawingml/2006/main">
             <a:fillRect l="0" t="0" r="0" b="0"/>
           </a:stretch>
@@ -40359,7 +40436,7 @@
           <p:nvPr/>
         </p:nvPicPr>
         <p:blipFill>
-          <a:blip xmlns:r="http://schemas.openxmlformats.org/officeDocument/2006/relationships" xmlns:a="http://schemas.openxmlformats.org/drawingml/2006/main" r:embed="R7b49e3dff8fd4683"/>
+          <a:blip xmlns:r="http://schemas.openxmlformats.org/officeDocument/2006/relationships" xmlns:a="http://schemas.openxmlformats.org/drawingml/2006/main" r:embed="R933ae5de28024bc5"/>
           <a:stretch xmlns:a="http://schemas.openxmlformats.org/drawingml/2006/main">
             <a:fillRect l="0" t="0" r="0" b="0"/>
           </a:stretch>
@@ -40885,7 +40962,7 @@
           <p:nvPr/>
         </p:nvPicPr>
         <p:blipFill>
-          <a:blip xmlns:r="http://schemas.openxmlformats.org/officeDocument/2006/relationships" xmlns:a="http://schemas.openxmlformats.org/drawingml/2006/main" r:embed="R7a8177ca8f384432"/>
+          <a:blip xmlns:r="http://schemas.openxmlformats.org/officeDocument/2006/relationships" xmlns:a="http://schemas.openxmlformats.org/drawingml/2006/main" r:embed="R6b9272e272364fb1"/>
           <a:stretch xmlns:a="http://schemas.openxmlformats.org/drawingml/2006/main">
             <a:fillRect l="0" t="0" r="0" b="0"/>
           </a:stretch>
@@ -41056,7 +41133,7 @@
           <p:nvPr/>
         </p:nvPicPr>
         <p:blipFill>
-          <a:blip xmlns:r="http://schemas.openxmlformats.org/officeDocument/2006/relationships" xmlns:a="http://schemas.openxmlformats.org/drawingml/2006/main" r:embed="R51e054f7c8334efb"/>
+          <a:blip xmlns:r="http://schemas.openxmlformats.org/officeDocument/2006/relationships" xmlns:a="http://schemas.openxmlformats.org/drawingml/2006/main" r:embed="Ra3a15dee2d344b1a"/>
           <a:stretch xmlns:a="http://schemas.openxmlformats.org/drawingml/2006/main">
             <a:fillRect l="0" t="0" r="0" b="0"/>
           </a:stretch>
@@ -41080,7 +41157,7 @@
           <p:nvPr/>
         </p:nvPicPr>
         <p:blipFill>
-          <a:blip xmlns:r="http://schemas.openxmlformats.org/officeDocument/2006/relationships" xmlns:a="http://schemas.openxmlformats.org/drawingml/2006/main" r:embed="Rabf22a0e0ba6489c"/>
+          <a:blip xmlns:r="http://schemas.openxmlformats.org/officeDocument/2006/relationships" xmlns:a="http://schemas.openxmlformats.org/drawingml/2006/main" r:embed="R209aec1866e2470a"/>
           <a:stretch xmlns:a="http://schemas.openxmlformats.org/drawingml/2006/main">
             <a:fillRect l="0" t="0" r="0" b="0"/>
           </a:stretch>
@@ -41606,7 +41683,7 @@
           <p:nvPr/>
         </p:nvPicPr>
         <p:blipFill>
-          <a:blip xmlns:r="http://schemas.openxmlformats.org/officeDocument/2006/relationships" xmlns:a="http://schemas.openxmlformats.org/drawingml/2006/main" r:embed="R49db9aefbc1248ee"/>
+          <a:blip xmlns:r="http://schemas.openxmlformats.org/officeDocument/2006/relationships" xmlns:a="http://schemas.openxmlformats.org/drawingml/2006/main" r:embed="R63f149a148af4480"/>
           <a:stretch xmlns:a="http://schemas.openxmlformats.org/drawingml/2006/main">
             <a:fillRect l="0" t="0" r="0" b="0"/>
           </a:stretch>
@@ -41898,7 +41975,7 @@
           <p:nvPr/>
         </p:nvPicPr>
         <p:blipFill>
-          <a:blip xmlns:r="http://schemas.openxmlformats.org/officeDocument/2006/relationships" xmlns:a="http://schemas.openxmlformats.org/drawingml/2006/main" r:embed="R0627f998719d43f4"/>
+          <a:blip xmlns:r="http://schemas.openxmlformats.org/officeDocument/2006/relationships" xmlns:a="http://schemas.openxmlformats.org/drawingml/2006/main" r:embed="R3203819cbd204024"/>
           <a:stretch xmlns:a="http://schemas.openxmlformats.org/drawingml/2006/main">
             <a:fillRect l="0" t="0" r="0" b="0"/>
           </a:stretch>
@@ -41922,7 +41999,7 @@
           <p:nvPr/>
         </p:nvPicPr>
         <p:blipFill>
-          <a:blip xmlns:r="http://schemas.openxmlformats.org/officeDocument/2006/relationships" xmlns:a="http://schemas.openxmlformats.org/drawingml/2006/main" r:embed="R2b9eaa1ef7604c39"/>
+          <a:blip xmlns:r="http://schemas.openxmlformats.org/officeDocument/2006/relationships" xmlns:a="http://schemas.openxmlformats.org/drawingml/2006/main" r:embed="Ra797881a9f804d5b"/>
           <a:stretch xmlns:a="http://schemas.openxmlformats.org/drawingml/2006/main">
             <a:fillRect l="0" t="0" r="0" b="0"/>
           </a:stretch>
@@ -42288,7 +42365,7 @@
           <p:nvPr/>
         </p:nvPicPr>
         <p:blipFill>
-          <a:blip xmlns:r="http://schemas.openxmlformats.org/officeDocument/2006/relationships" xmlns:a="http://schemas.openxmlformats.org/drawingml/2006/main" r:embed="R089abf0450494864"/>
+          <a:blip xmlns:r="http://schemas.openxmlformats.org/officeDocument/2006/relationships" xmlns:a="http://schemas.openxmlformats.org/drawingml/2006/main" r:embed="R65b8377fffd94ee6"/>
           <a:stretch xmlns:a="http://schemas.openxmlformats.org/drawingml/2006/main">
             <a:fillRect l="0" t="0" r="0" b="0"/>
           </a:stretch>
@@ -42312,7 +42389,7 @@
           <p:nvPr/>
         </p:nvPicPr>
         <p:blipFill>
-          <a:blip xmlns:r="http://schemas.openxmlformats.org/officeDocument/2006/relationships" xmlns:a="http://schemas.openxmlformats.org/drawingml/2006/main" r:embed="R731e3f4661244c33"/>
+          <a:blip xmlns:r="http://schemas.openxmlformats.org/officeDocument/2006/relationships" xmlns:a="http://schemas.openxmlformats.org/drawingml/2006/main" r:embed="R8ba83b4001724187"/>
           <a:stretch xmlns:a="http://schemas.openxmlformats.org/drawingml/2006/main">
             <a:fillRect l="0" t="0" r="0" b="0"/>
           </a:stretch>
@@ -43245,7 +43322,7 @@
           <p:nvPr/>
         </p:nvPicPr>
         <p:blipFill>
-          <a:blip xmlns:r="http://schemas.openxmlformats.org/officeDocument/2006/relationships" xmlns:a="http://schemas.openxmlformats.org/drawingml/2006/main" r:embed="R356b5ed4e29c425c"/>
+          <a:blip xmlns:r="http://schemas.openxmlformats.org/officeDocument/2006/relationships" xmlns:a="http://schemas.openxmlformats.org/drawingml/2006/main" r:embed="Rdb72b0a17ba94c85"/>
           <a:stretch xmlns:a="http://schemas.openxmlformats.org/drawingml/2006/main">
             <a:fillRect l="0" t="0" r="0" b="0"/>
           </a:stretch>
@@ -43361,7 +43438,7 @@
           <p:nvPr/>
         </p:nvPicPr>
         <p:blipFill>
-          <a:blip xmlns:r="http://schemas.openxmlformats.org/officeDocument/2006/relationships" xmlns:a="http://schemas.openxmlformats.org/drawingml/2006/main" r:embed="R356b5ed4e29c425c"/>
+          <a:blip xmlns:r="http://schemas.openxmlformats.org/officeDocument/2006/relationships" xmlns:a="http://schemas.openxmlformats.org/drawingml/2006/main" r:embed="Rdb72b0a17ba94c85"/>
           <a:stretch xmlns:a="http://schemas.openxmlformats.org/drawingml/2006/main">
             <a:fillRect l="0" t="0" r="0" b="0"/>
           </a:stretch>
@@ -43477,7 +43554,7 @@
           <p:nvPr/>
         </p:nvPicPr>
         <p:blipFill>
-          <a:blip xmlns:r="http://schemas.openxmlformats.org/officeDocument/2006/relationships" xmlns:a="http://schemas.openxmlformats.org/drawingml/2006/main" r:embed="R356b5ed4e29c425c"/>
+          <a:blip xmlns:r="http://schemas.openxmlformats.org/officeDocument/2006/relationships" xmlns:a="http://schemas.openxmlformats.org/drawingml/2006/main" r:embed="Rdb72b0a17ba94c85"/>
           <a:stretch xmlns:a="http://schemas.openxmlformats.org/drawingml/2006/main">
             <a:fillRect l="0" t="0" r="0" b="0"/>
           </a:stretch>
@@ -43593,7 +43670,7 @@
           <p:nvPr/>
         </p:nvPicPr>
         <p:blipFill>
-          <a:blip xmlns:r="http://schemas.openxmlformats.org/officeDocument/2006/relationships" xmlns:a="http://schemas.openxmlformats.org/drawingml/2006/main" r:embed="R356b5ed4e29c425c"/>
+          <a:blip xmlns:r="http://schemas.openxmlformats.org/officeDocument/2006/relationships" xmlns:a="http://schemas.openxmlformats.org/drawingml/2006/main" r:embed="Rdb72b0a17ba94c85"/>
           <a:stretch xmlns:a="http://schemas.openxmlformats.org/drawingml/2006/main">
             <a:fillRect l="0" t="0" r="0" b="0"/>
           </a:stretch>
@@ -43709,7 +43786,7 @@
           <p:nvPr/>
         </p:nvPicPr>
         <p:blipFill>
-          <a:blip xmlns:r="http://schemas.openxmlformats.org/officeDocument/2006/relationships" xmlns:a="http://schemas.openxmlformats.org/drawingml/2006/main" r:embed="Re070f01096cf468d"/>
+          <a:blip xmlns:r="http://schemas.openxmlformats.org/officeDocument/2006/relationships" xmlns:a="http://schemas.openxmlformats.org/drawingml/2006/main" r:embed="R46e268f2ddcc4836"/>
           <a:stretch xmlns:a="http://schemas.openxmlformats.org/drawingml/2006/main">
             <a:fillRect l="0" t="0" r="0" b="0"/>
           </a:stretch>
@@ -43825,7 +43902,7 @@
           <p:nvPr/>
         </p:nvPicPr>
         <p:blipFill>
-          <a:blip xmlns:r="http://schemas.openxmlformats.org/officeDocument/2006/relationships" xmlns:a="http://schemas.openxmlformats.org/drawingml/2006/main" r:embed="Re070f01096cf468d"/>
+          <a:blip xmlns:r="http://schemas.openxmlformats.org/officeDocument/2006/relationships" xmlns:a="http://schemas.openxmlformats.org/drawingml/2006/main" r:embed="R46e268f2ddcc4836"/>
           <a:stretch xmlns:a="http://schemas.openxmlformats.org/drawingml/2006/main">
             <a:fillRect l="0" t="0" r="0" b="0"/>
           </a:stretch>
@@ -44095,7 +44172,7 @@
           <p:nvPr/>
         </p:nvPicPr>
         <p:blipFill>
-          <a:blip xmlns:r="http://schemas.openxmlformats.org/officeDocument/2006/relationships" xmlns:a="http://schemas.openxmlformats.org/drawingml/2006/main" r:embed="Ra6c578f05b2f4c66"/>
+          <a:blip xmlns:r="http://schemas.openxmlformats.org/officeDocument/2006/relationships" xmlns:a="http://schemas.openxmlformats.org/drawingml/2006/main" r:embed="R56a5d7ad365a4f83"/>
           <a:stretch xmlns:a="http://schemas.openxmlformats.org/drawingml/2006/main">
             <a:fillRect l="0" t="0" r="0" b="0"/>
           </a:stretch>
@@ -44119,7 +44196,7 @@
           <p:nvPr/>
         </p:nvPicPr>
         <p:blipFill>
-          <a:blip xmlns:r="http://schemas.openxmlformats.org/officeDocument/2006/relationships" xmlns:a="http://schemas.openxmlformats.org/drawingml/2006/main" r:embed="R99817aa2e2cd402b"/>
+          <a:blip xmlns:r="http://schemas.openxmlformats.org/officeDocument/2006/relationships" xmlns:a="http://schemas.openxmlformats.org/drawingml/2006/main" r:embed="Rb0cc871a230e4a96"/>
           <a:stretch xmlns:a="http://schemas.openxmlformats.org/drawingml/2006/main">
             <a:fillRect l="0" t="0" r="0" b="0"/>
           </a:stretch>
@@ -45086,7 +45163,7 @@
           <p:nvPr/>
         </p:nvPicPr>
         <p:blipFill>
-          <a:blip xmlns:r="http://schemas.openxmlformats.org/officeDocument/2006/relationships" xmlns:a="http://schemas.openxmlformats.org/drawingml/2006/main" r:embed="R844d48b4296546eb"/>
+          <a:blip xmlns:r="http://schemas.openxmlformats.org/officeDocument/2006/relationships" xmlns:a="http://schemas.openxmlformats.org/drawingml/2006/main" r:embed="R333a3aebe3d142d3"/>
           <a:stretch xmlns:a="http://schemas.openxmlformats.org/drawingml/2006/main">
             <a:fillRect l="0" t="0" r="0" b="0"/>
           </a:stretch>
@@ -45110,7 +45187,7 @@
           <p:nvPr/>
         </p:nvPicPr>
         <p:blipFill>
-          <a:blip xmlns:r="http://schemas.openxmlformats.org/officeDocument/2006/relationships" xmlns:a="http://schemas.openxmlformats.org/drawingml/2006/main" r:embed="R6aef48b1a7814e72"/>
+          <a:blip xmlns:r="http://schemas.openxmlformats.org/officeDocument/2006/relationships" xmlns:a="http://schemas.openxmlformats.org/drawingml/2006/main" r:embed="R65baa580deef42e6"/>
           <a:stretch xmlns:a="http://schemas.openxmlformats.org/drawingml/2006/main">
             <a:fillRect l="0" t="0" r="0" b="0"/>
           </a:stretch>
@@ -45476,7 +45553,7 @@
           <p:nvPr/>
         </p:nvPicPr>
         <p:blipFill>
-          <a:blip xmlns:r="http://schemas.openxmlformats.org/officeDocument/2006/relationships" xmlns:a="http://schemas.openxmlformats.org/drawingml/2006/main" r:embed="R1d163c557dd749f2"/>
+          <a:blip xmlns:r="http://schemas.openxmlformats.org/officeDocument/2006/relationships" xmlns:a="http://schemas.openxmlformats.org/drawingml/2006/main" r:embed="R7c92a22325e5470b"/>
           <a:stretch xmlns:a="http://schemas.openxmlformats.org/drawingml/2006/main">
             <a:fillRect l="0" t="0" r="0" b="0"/>
           </a:stretch>
@@ -45500,7 +45577,7 @@
           <p:nvPr/>
         </p:nvPicPr>
         <p:blipFill>
-          <a:blip xmlns:r="http://schemas.openxmlformats.org/officeDocument/2006/relationships" xmlns:a="http://schemas.openxmlformats.org/drawingml/2006/main" r:embed="R58844a4146304ce0"/>
+          <a:blip xmlns:r="http://schemas.openxmlformats.org/officeDocument/2006/relationships" xmlns:a="http://schemas.openxmlformats.org/drawingml/2006/main" r:embed="R60578d5e728545b0"/>
           <a:stretch xmlns:a="http://schemas.openxmlformats.org/drawingml/2006/main">
             <a:fillRect l="0" t="0" r="0" b="0"/>
           </a:stretch>
@@ -46660,7 +46737,7 @@
           <p:nvPr/>
         </p:nvPicPr>
         <p:blipFill>
-          <a:blip xmlns:r="http://schemas.openxmlformats.org/officeDocument/2006/relationships" xmlns:a="http://schemas.openxmlformats.org/drawingml/2006/main" r:embed="R0b675ad0c19247d4"/>
+          <a:blip xmlns:r="http://schemas.openxmlformats.org/officeDocument/2006/relationships" xmlns:a="http://schemas.openxmlformats.org/drawingml/2006/main" r:embed="Rdb532665a91a4cd9"/>
           <a:stretch xmlns:a="http://schemas.openxmlformats.org/drawingml/2006/main">
             <a:fillRect l="0" t="0" r="0" b="0"/>
           </a:stretch>
@@ -46684,7 +46761,7 @@
           <p:nvPr/>
         </p:nvPicPr>
         <p:blipFill>
-          <a:blip xmlns:r="http://schemas.openxmlformats.org/officeDocument/2006/relationships" xmlns:a="http://schemas.openxmlformats.org/drawingml/2006/main" r:embed="R93c693ebd3f441c6"/>
+          <a:blip xmlns:r="http://schemas.openxmlformats.org/officeDocument/2006/relationships" xmlns:a="http://schemas.openxmlformats.org/drawingml/2006/main" r:embed="Rd36d3a7870464374"/>
           <a:stretch xmlns:a="http://schemas.openxmlformats.org/drawingml/2006/main">
             <a:fillRect l="0" t="0" r="0" b="0"/>
           </a:stretch>

</xml_diff>